<commit_message>
feat(pitch): update team roles and specializations in presentation
</commit_message>
<xml_diff>
--- a/docs/TuT_AI_Marketing_Pitch_Deck.pptx
+++ b/docs/TuT_AI_Marketing_Pitch_Deck.pptx
@@ -3264,7 +3264,7 @@
               </a:defRPr>
             </a:pPr>
             <a:r>
-              <a:t>Project Lead: Ahmed Gamal Sophi Arfa | Under the Supervision of MCIT Leadership</a:t>
+              <a:t>Principal Architect &amp; Project Lead: Ahmed Gamal Sophi Arfa | Under the Supervision of MCIT Leadership</a:t>
             </a:r>
           </a:p>
         </p:txBody>
@@ -4298,13 +4298,13 @@
               </a:spcAft>
               <a:defRPr sz="1000">
                 <a:solidFill>
-                  <a:srgbClr val="94A3B8"/>
-                </a:solidFill>
-                <a:latin typeface="Arial"/>
-              </a:defRPr>
-            </a:pPr>
-            <a:r>
-              <a:t>     Project Lead &amp; Core AI Architect (Lead)</a:t>
+                  <a:srgbClr val="F5D673"/>
+                </a:solidFill>
+                <a:latin typeface="Arial"/>
+              </a:defRPr>
+            </a:pPr>
+            <a:r>
+              <a:t>     Project Lead, Principal Architect &amp; Full-Stack Creator (End-to-End Platform)</a:t>
             </a:r>
           </a:p>
           <a:p>
@@ -4333,7 +4333,7 @@
               </a:defRPr>
             </a:pPr>
             <a:r>
-              <a:t>     Systems &amp; Fullstack Engineer</a:t>
+              <a:t>     RAG Specialist (Retrieval-Augmented Generation &amp; Vector Search)</a:t>
             </a:r>
           </a:p>
           <a:p>
@@ -4362,7 +4362,7 @@
               </a:defRPr>
             </a:pPr>
             <a:r>
-              <a:t>     Data Engineering &amp; Research Workflows</a:t>
+              <a:t>     Infographics Specialist (VectorCraft Studio &amp; Visual Storytelling)</a:t>
             </a:r>
           </a:p>
           <a:p>
@@ -4391,7 +4391,7 @@
               </a:defRPr>
             </a:pPr>
             <a:r>
-              <a:t>     Backend &amp; Integration Specialist</a:t>
+              <a:t>     Presentation Engine Specialist (DeckCraft &amp; Slide Generation)</a:t>
             </a:r>
           </a:p>
           <a:p>
@@ -4420,7 +4420,7 @@
               </a:defRPr>
             </a:pPr>
             <a:r>
-              <a:t>     UI/UX &amp; Frontend Platform Specialist</a:t>
+              <a:t>     Presentation Design Specialist (DeckCraft &amp; Slide Layouts)</a:t>
             </a:r>
           </a:p>
           <a:p>
@@ -4449,7 +4449,7 @@
               </a:defRPr>
             </a:pPr>
             <a:r>
-              <a:t>     DevOps &amp; Infrastructure Engineer</a:t>
+              <a:t>     RAG Pipeline Specialist (Knowledge Ingestion &amp; Chunking)</a:t>
             </a:r>
           </a:p>
         </p:txBody>

</xml_diff>

<commit_message>
feat(pitch): simplify development journey into 4 phases and clean team presentation slide
</commit_message>
<xml_diff>
--- a/docs/TuT_AI_Marketing_Pitch_Deck.pptx
+++ b/docs/TuT_AI_Marketing_Pitch_Deck.pptx
@@ -4119,7 +4119,10 @@
           </a:p>
           <a:p>
             <a:pPr>
-              <a:defRPr sz="1400" b="1">
+              <a:spcAft>
+                <a:spcPts val="2000"/>
+              </a:spcAft>
+              <a:defRPr sz="1500" b="1">
                 <a:solidFill>
                   <a:srgbClr val="F5D673"/>
                 </a:solidFill>
@@ -4133,22 +4136,9 @@
           <a:p>
             <a:pPr>
               <a:spcAft>
-                <a:spcPts val="1000"/>
-              </a:spcAft>
-              <a:defRPr sz="1100">
-                <a:solidFill>
-                  <a:srgbClr val="94A3B8"/>
-                </a:solidFill>
-                <a:latin typeface="Arial"/>
-              </a:defRPr>
-            </a:pPr>
-            <a:r>
-              <a:t>     Ministry Leadership &amp; Project Sponsor</a:t>
-            </a:r>
-          </a:p>
-          <a:p>
-            <a:pPr>
-              <a:defRPr sz="1400" b="1">
+                <a:spcPts val="2000"/>
+              </a:spcAft>
+              <a:defRPr sz="1500" b="1">
                 <a:solidFill>
                   <a:srgbClr val="F5D673"/>
                 </a:solidFill>
@@ -4162,22 +4152,9 @@
           <a:p>
             <a:pPr>
               <a:spcAft>
-                <a:spcPts val="1000"/>
-              </a:spcAft>
-              <a:defRPr sz="1100">
-                <a:solidFill>
-                  <a:srgbClr val="94A3B8"/>
-                </a:solidFill>
-                <a:latin typeface="Arial"/>
-              </a:defRPr>
-            </a:pPr>
-            <a:r>
-              <a:t>     Technical Oversight &amp; Ministerial Direction</a:t>
-            </a:r>
-          </a:p>
-          <a:p>
-            <a:pPr>
-              <a:defRPr sz="1400" b="1">
+                <a:spcPts val="2000"/>
+              </a:spcAft>
+              <a:defRPr sz="1500" b="1">
                 <a:solidFill>
                   <a:srgbClr val="F5D673"/>
                 </a:solidFill>
@@ -4186,22 +4163,6 @@
             </a:pPr>
             <a:r>
               <a:t>🎖️  Eng. Mohamed Khalid Mohamed Roshdy</a:t>
-            </a:r>
-          </a:p>
-          <a:p>
-            <a:pPr>
-              <a:spcAft>
-                <a:spcPts val="1000"/>
-              </a:spcAft>
-              <a:defRPr sz="1100">
-                <a:solidFill>
-                  <a:srgbClr val="94A3B8"/>
-                </a:solidFill>
-                <a:latin typeface="Arial"/>
-              </a:defRPr>
-            </a:pPr>
-            <a:r>
-              <a:t>     Strategic Engineering &amp; Systems Supervision</a:t>
             </a:r>
           </a:p>
         </p:txBody>
@@ -4265,9 +4226,41 @@
           <a:p>
             <a:pPr>
               <a:spcAft>
+                <a:spcPts val="1600"/>
+              </a:spcAft>
+              <a:defRPr sz="1800" b="1">
+                <a:solidFill>
+                  <a:srgbClr val="F8FAFC"/>
+                </a:solidFill>
+                <a:latin typeface="Arial"/>
+              </a:defRPr>
+            </a:pPr>
+            <a:r>
+              <a:t>TuT AI Core Team</a:t>
+            </a:r>
+          </a:p>
+          <a:p>
+            <a:pPr>
+              <a:spcAft>
                 <a:spcPts val="1200"/>
               </a:spcAft>
-              <a:defRPr sz="1800" b="1">
+              <a:defRPr sz="1400" b="1">
+                <a:solidFill>
+                  <a:srgbClr val="D4AF37"/>
+                </a:solidFill>
+                <a:latin typeface="Arial"/>
+              </a:defRPr>
+            </a:pPr>
+            <a:r>
+              <a:t>⭐  Ahmed Gamal Sophi Arfa</a:t>
+            </a:r>
+          </a:p>
+          <a:p>
+            <a:pPr>
+              <a:spcAft>
+                <a:spcPts val="800"/>
+              </a:spcAft>
+              <a:defRPr sz="1300" b="1">
                 <a:solidFill>
                   <a:srgbClr val="F8FAFC"/>
                 </a:solidFill>
@@ -4275,41 +4268,15 @@
               </a:defRPr>
             </a:pPr>
             <a:r>
-              <a:t>TuT AI Core Contributors</a:t>
-            </a:r>
-          </a:p>
-          <a:p>
-            <a:pPr>
-              <a:defRPr sz="1200" b="1">
-                <a:solidFill>
-                  <a:srgbClr val="D4AF37"/>
-                </a:solidFill>
-                <a:latin typeface="Arial"/>
-              </a:defRPr>
-            </a:pPr>
-            <a:r>
-              <a:t>⭐  Ahmed Gamal Sophi Arfa</a:t>
-            </a:r>
-          </a:p>
-          <a:p>
-            <a:pPr>
-              <a:spcAft>
-                <a:spcPts val="400"/>
-              </a:spcAft>
-              <a:defRPr sz="1000">
-                <a:solidFill>
-                  <a:srgbClr val="F5D673"/>
-                </a:solidFill>
-                <a:latin typeface="Arial"/>
-              </a:defRPr>
-            </a:pPr>
-            <a:r>
-              <a:t>     Project Lead, Principal Architect &amp; Full-Stack Creator (End-to-End Platform)</a:t>
-            </a:r>
-          </a:p>
-          <a:p>
-            <a:pPr>
-              <a:defRPr sz="1200" b="1">
+              <a:t>•  Abdelrhman Mahmoud Fawzy</a:t>
+            </a:r>
+          </a:p>
+          <a:p>
+            <a:pPr>
+              <a:spcAft>
+                <a:spcPts val="800"/>
+              </a:spcAft>
+              <a:defRPr sz="1300" b="1">
                 <a:solidFill>
                   <a:srgbClr val="F8FAFC"/>
                 </a:solidFill>
@@ -4317,28 +4284,15 @@
               </a:defRPr>
             </a:pPr>
             <a:r>
-              <a:t>•  Abdelrhman Mahmoud Fawzy</a:t>
-            </a:r>
-          </a:p>
-          <a:p>
-            <a:pPr>
-              <a:spcAft>
-                <a:spcPts val="400"/>
-              </a:spcAft>
-              <a:defRPr sz="1000">
-                <a:solidFill>
-                  <a:srgbClr val="94A3B8"/>
-                </a:solidFill>
-                <a:latin typeface="Arial"/>
-              </a:defRPr>
-            </a:pPr>
-            <a:r>
-              <a:t>     RAG Specialist (Retrieval-Augmented Generation &amp; Vector Search)</a:t>
-            </a:r>
-          </a:p>
-          <a:p>
-            <a:pPr>
-              <a:defRPr sz="1200" b="1">
+              <a:t>•  Saja Raafat Gaber</a:t>
+            </a:r>
+          </a:p>
+          <a:p>
+            <a:pPr>
+              <a:spcAft>
+                <a:spcPts val="800"/>
+              </a:spcAft>
+              <a:defRPr sz="1300" b="1">
                 <a:solidFill>
                   <a:srgbClr val="F8FAFC"/>
                 </a:solidFill>
@@ -4346,28 +4300,15 @@
               </a:defRPr>
             </a:pPr>
             <a:r>
-              <a:t>•  Saja Raafat Gaber</a:t>
-            </a:r>
-          </a:p>
-          <a:p>
-            <a:pPr>
-              <a:spcAft>
-                <a:spcPts val="400"/>
-              </a:spcAft>
-              <a:defRPr sz="1000">
-                <a:solidFill>
-                  <a:srgbClr val="94A3B8"/>
-                </a:solidFill>
-                <a:latin typeface="Arial"/>
-              </a:defRPr>
-            </a:pPr>
-            <a:r>
-              <a:t>     Infographics Specialist (VectorCraft Studio &amp; Visual Storytelling)</a:t>
-            </a:r>
-          </a:p>
-          <a:p>
-            <a:pPr>
-              <a:defRPr sz="1200" b="1">
+              <a:t>•  Mohamed Hamdy Abdelazez</a:t>
+            </a:r>
+          </a:p>
+          <a:p>
+            <a:pPr>
+              <a:spcAft>
+                <a:spcPts val="800"/>
+              </a:spcAft>
+              <a:defRPr sz="1300" b="1">
                 <a:solidFill>
                   <a:srgbClr val="F8FAFC"/>
                 </a:solidFill>
@@ -4375,28 +4316,15 @@
               </a:defRPr>
             </a:pPr>
             <a:r>
-              <a:t>•  Mohamed Hamdy Abdelazez</a:t>
-            </a:r>
-          </a:p>
-          <a:p>
-            <a:pPr>
-              <a:spcAft>
-                <a:spcPts val="400"/>
-              </a:spcAft>
-              <a:defRPr sz="1000">
-                <a:solidFill>
-                  <a:srgbClr val="94A3B8"/>
-                </a:solidFill>
-                <a:latin typeface="Arial"/>
-              </a:defRPr>
-            </a:pPr>
-            <a:r>
-              <a:t>     Presentation Engine Specialist (DeckCraft &amp; Slide Generation)</a:t>
-            </a:r>
-          </a:p>
-          <a:p>
-            <a:pPr>
-              <a:defRPr sz="1200" b="1">
+              <a:t>•  Asmaa Samy Hagag</a:t>
+            </a:r>
+          </a:p>
+          <a:p>
+            <a:pPr>
+              <a:spcAft>
+                <a:spcPts val="800"/>
+              </a:spcAft>
+              <a:defRPr sz="1300" b="1">
                 <a:solidFill>
                   <a:srgbClr val="F8FAFC"/>
                 </a:solidFill>
@@ -4404,52 +4332,7 @@
               </a:defRPr>
             </a:pPr>
             <a:r>
-              <a:t>•  Asmaa Samy Hagag</a:t>
-            </a:r>
-          </a:p>
-          <a:p>
-            <a:pPr>
-              <a:spcAft>
-                <a:spcPts val="400"/>
-              </a:spcAft>
-              <a:defRPr sz="1000">
-                <a:solidFill>
-                  <a:srgbClr val="94A3B8"/>
-                </a:solidFill>
-                <a:latin typeface="Arial"/>
-              </a:defRPr>
-            </a:pPr>
-            <a:r>
-              <a:t>     Presentation Design Specialist (DeckCraft &amp; Slide Layouts)</a:t>
-            </a:r>
-          </a:p>
-          <a:p>
-            <a:pPr>
-              <a:defRPr sz="1200" b="1">
-                <a:solidFill>
-                  <a:srgbClr val="F8FAFC"/>
-                </a:solidFill>
-                <a:latin typeface="Arial"/>
-              </a:defRPr>
-            </a:pPr>
-            <a:r>
               <a:t>•  Mohamed Abd elhgani el kwatihy</a:t>
-            </a:r>
-          </a:p>
-          <a:p>
-            <a:pPr>
-              <a:spcAft>
-                <a:spcPts val="400"/>
-              </a:spcAft>
-              <a:defRPr sz="1000">
-                <a:solidFill>
-                  <a:srgbClr val="94A3B8"/>
-                </a:solidFill>
-                <a:latin typeface="Arial"/>
-              </a:defRPr>
-            </a:pPr>
-            <a:r>
-              <a:t>     RAG Pipeline Specialist (Knowledge Ingestion &amp; Chunking)</a:t>
             </a:r>
           </a:p>
         </p:txBody>
@@ -7821,7 +7704,7 @@
               </a:defRPr>
             </a:pPr>
             <a:r>
-              <a:t>IDENTITY &amp; HERITAGE</a:t>
+              <a:t>ENGINEERING MILESTONES</a:t>
             </a:r>
           </a:p>
         </p:txBody>
@@ -7857,7 +7740,7 @@
               </a:defRPr>
             </a:pPr>
             <a:r>
-              <a:t>Egyptian Sovereign Persona Suite &amp; Cultural Alignment</a:t>
+              <a:t>The Development Journey: 4 Evolutionary Phases</a:t>
             </a:r>
           </a:p>
         </p:txBody>
@@ -7914,7 +7797,7 @@
         <p:spPr>
           <a:xfrm>
             <a:off x="731520" y="1645920"/>
-            <a:ext cx="5212080" cy="4572000"/>
+            <a:ext cx="5212080" cy="2194560"/>
           </a:xfrm>
           <a:prstGeom prst="roundRect">
             <a:avLst/>
@@ -7958,7 +7841,7 @@
               </a:defRPr>
             </a:pPr>
             <a:r>
-              <a:t>PERSONA GALLERY</a:t>
+              <a:t>PHASE 1: INCEPTION</a:t>
             </a:r>
           </a:p>
           <a:p>
@@ -7974,7 +7857,7 @@
               </a:defRPr>
             </a:pPr>
             <a:r>
-              <a:t>10 Sovereign Egyptian Historical Personas</a:t>
+              <a:t>Phase 1: Foundation &amp; Sovereign Identity</a:t>
             </a:r>
           </a:p>
           <a:p>
@@ -7990,7 +7873,7 @@
               </a:defRPr>
             </a:pPr>
             <a:r>
-              <a:t>•  Rooted in Heritage: Completely replaced generic western AI branding with iconic figures of Egyptian history.</a:t>
+              <a:t>•  Transitioned away from generic third-party code to 100% Egyptian sovereign platform.</a:t>
             </a:r>
           </a:p>
           <a:p>
@@ -8006,55 +7889,7 @@
               </a:defRPr>
             </a:pPr>
             <a:r>
-              <a:t>•  King Tut: The Sovereign Prime Agent — strategic leadership, presentation compiler, and executive director.</a:t>
-            </a:r>
-          </a:p>
-          <a:p>
-            <a:pPr>
-              <a:spcAft>
-                <a:spcPts val="600"/>
-              </a:spcAft>
-              <a:defRPr sz="1200">
-                <a:solidFill>
-                  <a:srgbClr val="94A3B8"/>
-                </a:solidFill>
-                <a:latin typeface="Arial"/>
-              </a:defRPr>
-            </a:pPr>
-            <a:r>
-              <a:t>•  Imhotep: Chief Architect &amp; Engineer — data structures, code analysis, mathematical auditing, and spreadsheets.</a:t>
-            </a:r>
-          </a:p>
-          <a:p>
-            <a:pPr>
-              <a:spcAft>
-                <a:spcPts val="600"/>
-              </a:spcAft>
-              <a:defRPr sz="1200">
-                <a:solidFill>
-                  <a:srgbClr val="94A3B8"/>
-                </a:solidFill>
-                <a:latin typeface="Arial"/>
-              </a:defRPr>
-            </a:pPr>
-            <a:r>
-              <a:t>•  Thoth: The Scribe of Wisdom — research synthesis, deep summarization, document validation, and historical records.</a:t>
-            </a:r>
-          </a:p>
-          <a:p>
-            <a:pPr>
-              <a:spcAft>
-                <a:spcPts val="600"/>
-              </a:spcAft>
-              <a:defRPr sz="1200">
-                <a:solidFill>
-                  <a:srgbClr val="94A3B8"/>
-                </a:solidFill>
-                <a:latin typeface="Arial"/>
-              </a:defRPr>
-            </a:pPr>
-            <a:r>
-              <a:t>•  Horus, Akhenaten, Nefertiti: Specialized defense, governance, and administrative communication agents.</a:t>
+              <a:t>•  Engineered the TuT AI identity: 10 historical personas &amp; 3D holographic cartouche.</a:t>
             </a:r>
           </a:p>
         </p:txBody>
@@ -8068,7 +7903,7 @@
         <p:spPr>
           <a:xfrm>
             <a:off x="6217920" y="1645920"/>
-            <a:ext cx="5212080" cy="4572000"/>
+            <a:ext cx="5212080" cy="2194560"/>
           </a:xfrm>
           <a:prstGeom prst="roundRect">
             <a:avLst/>
@@ -8112,7 +7947,7 @@
               </a:defRPr>
             </a:pPr>
             <a:r>
-              <a:t>USER EXPERIENCE</a:t>
+              <a:t>PHASE 2: ARCHITECTURE</a:t>
             </a:r>
           </a:p>
           <a:p>
@@ -8128,7 +7963,7 @@
               </a:defRPr>
             </a:pPr>
             <a:r>
-              <a:t>Holographic 3D Portrait &amp; Quick-Switcher</a:t>
+              <a:t>Phase 2: Core Engines &amp; Resilient Fixes</a:t>
             </a:r>
           </a:p>
           <a:p>
@@ -8144,7 +7979,7 @@
               </a:defRPr>
             </a:pPr>
             <a:r>
-              <a:t>•  3D Transparent Holographic Avatar: Modeled with an obsidian cartouche and royal gold illuminated rim.</a:t>
+              <a:t>•  Engineered the 3 pillars: Deep Summarization, DeckCraft (.pptx), and VectorCraft (infographics).</a:t>
             </a:r>
           </a:p>
           <a:p>
@@ -8160,7 +7995,81 @@
               </a:defRPr>
             </a:pPr>
             <a:r>
-              <a:t>•  1-Click Avatar Switcher: A dedicated horizontal selector bar in the header allows instantaneous switching between all 10 personas.</a:t>
+              <a:t>•  Resolved TRPC runtime crashes via intelligent local Ollama fallback proxy.</a:t>
+            </a:r>
+          </a:p>
+        </p:txBody>
+      </p:sp>
+      <p:sp>
+        <p:nvSpPr>
+          <p:cNvPr id="8" name="Rounded Rectangle 7"/>
+          <p:cNvSpPr/>
+          <p:nvPr/>
+        </p:nvSpPr>
+        <p:spPr>
+          <a:xfrm>
+            <a:off x="731520" y="4023360"/>
+            <a:ext cx="5212080" cy="2194560"/>
+          </a:xfrm>
+          <a:prstGeom prst="roundRect">
+            <a:avLst/>
+          </a:prstGeom>
+          <a:solidFill>
+            <a:srgbClr val="111827"/>
+          </a:solidFill>
+          <a:ln w="15240">
+            <a:solidFill>
+              <a:srgbClr val="34D399"/>
+            </a:solidFill>
+          </a:ln>
+        </p:spPr>
+        <p:style>
+          <a:lnRef idx="1">
+            <a:schemeClr val="accent1"/>
+          </a:lnRef>
+          <a:fillRef idx="3">
+            <a:schemeClr val="accent1"/>
+          </a:fillRef>
+          <a:effectRef idx="2">
+            <a:schemeClr val="accent1"/>
+          </a:effectRef>
+          <a:fontRef idx="minor">
+            <a:schemeClr val="lt1"/>
+          </a:fontRef>
+        </p:style>
+        <p:txBody>
+          <a:bodyPr rtlCol="0" anchor="ctr" wrap="square" lIns="228600" rIns="228600" tIns="228600" bIns="182880"/>
+          <a:lstStyle/>
+          <a:p>
+            <a:pPr algn="ctr">
+              <a:spcAft>
+                <a:spcPts val="400"/>
+              </a:spcAft>
+              <a:defRPr sz="1000" b="1">
+                <a:solidFill>
+                  <a:srgbClr val="34D399"/>
+                </a:solidFill>
+                <a:latin typeface="Arial"/>
+              </a:defRPr>
+            </a:pPr>
+            <a:r>
+              <a:t>PHASE 3: INTELLIGENCE</a:t>
+            </a:r>
+          </a:p>
+          <a:p>
+            <a:pPr>
+              <a:spcAft>
+                <a:spcPts val="1000"/>
+              </a:spcAft>
+              <a:defRPr sz="1600" b="1">
+                <a:solidFill>
+                  <a:srgbClr val="F8FAFC"/>
+                </a:solidFill>
+                <a:latin typeface="Arial"/>
+              </a:defRPr>
+            </a:pPr>
+            <a:r>
+              <a:t>Phase 3: Model Intelligence &amp; GPU Velocity</a:t>
             </a:r>
           </a:p>
           <a:p>
@@ -8176,7 +8085,7 @@
               </a:defRPr>
             </a:pPr>
             <a:r>
-              <a:t>•  Universal Synchronization: Switching the persona synchronizes the avatar, role title, system prompt, and greeting across all platform agents.</a:t>
+              <a:t>•  Unlocked database to 131,072 context tokens, 16,384 output tokens, and 'pro' reasoning.</a:t>
             </a:r>
           </a:p>
           <a:p>
@@ -8192,7 +8101,113 @@
               </a:defRPr>
             </a:pPr>
             <a:r>
-              <a:t>•  No-Permission Blockers: Fully editable and clickable for all team members.</a:t>
+              <a:t>•  Pinned gemma4:e4b into NVIDIA RTX 4050 GPU VRAM (keep_alive: '-1') for instant streaming.</a:t>
+            </a:r>
+          </a:p>
+        </p:txBody>
+      </p:sp>
+      <p:sp>
+        <p:nvSpPr>
+          <p:cNvPr id="9" name="Rounded Rectangle 8"/>
+          <p:cNvSpPr/>
+          <p:nvPr/>
+        </p:nvSpPr>
+        <p:spPr>
+          <a:xfrm>
+            <a:off x="6217920" y="4023360"/>
+            <a:ext cx="5212080" cy="2194560"/>
+          </a:xfrm>
+          <a:prstGeom prst="roundRect">
+            <a:avLst/>
+          </a:prstGeom>
+          <a:solidFill>
+            <a:srgbClr val="111827"/>
+          </a:solidFill>
+          <a:ln w="15240">
+            <a:solidFill>
+              <a:srgbClr val="F59E0B"/>
+            </a:solidFill>
+          </a:ln>
+        </p:spPr>
+        <p:style>
+          <a:lnRef idx="1">
+            <a:schemeClr val="accent1"/>
+          </a:lnRef>
+          <a:fillRef idx="3">
+            <a:schemeClr val="accent1"/>
+          </a:fillRef>
+          <a:effectRef idx="2">
+            <a:schemeClr val="accent1"/>
+          </a:effectRef>
+          <a:fontRef idx="minor">
+            <a:schemeClr val="lt1"/>
+          </a:fontRef>
+        </p:style>
+        <p:txBody>
+          <a:bodyPr rtlCol="0" anchor="ctr" wrap="square" lIns="228600" rIns="228600" tIns="228600" bIns="182880"/>
+          <a:lstStyle/>
+          <a:p>
+            <a:pPr algn="ctr">
+              <a:spcAft>
+                <a:spcPts val="400"/>
+              </a:spcAft>
+              <a:defRPr sz="1000" b="1">
+                <a:solidFill>
+                  <a:srgbClr val="F59E0B"/>
+                </a:solidFill>
+                <a:latin typeface="Arial"/>
+              </a:defRPr>
+            </a:pPr>
+            <a:r>
+              <a:t>PHASE 4: PRODUCTION</a:t>
+            </a:r>
+          </a:p>
+          <a:p>
+            <a:pPr>
+              <a:spcAft>
+                <a:spcPts val="1000"/>
+              </a:spcAft>
+              <a:defRPr sz="1600" b="1">
+                <a:solidFill>
+                  <a:srgbClr val="F8FAFC"/>
+                </a:solidFill>
+                <a:latin typeface="Arial"/>
+              </a:defRPr>
+            </a:pPr>
+            <a:r>
+              <a:t>Phase 4: Turnkey Production &amp; GitHub Release</a:t>
+            </a:r>
+          </a:p>
+          <a:p>
+            <a:pPr>
+              <a:spcAft>
+                <a:spcPts val="600"/>
+              </a:spcAft>
+              <a:defRPr sz="1200">
+                <a:solidFill>
+                  <a:srgbClr val="94A3B8"/>
+                </a:solidFill>
+                <a:latin typeface="Arial"/>
+              </a:defRPr>
+            </a:pPr>
+            <a:r>
+              <a:t>•  Built self-healing Docker architecture and turnkey 1-click setup scripts (.ps1 and .sh).</a:t>
+            </a:r>
+          </a:p>
+          <a:p>
+            <a:pPr>
+              <a:spcAft>
+                <a:spcPts val="600"/>
+              </a:spcAft>
+              <a:defRPr sz="1200">
+                <a:solidFill>
+                  <a:srgbClr val="94A3B8"/>
+                </a:solidFill>
+                <a:latin typeface="Arial"/>
+              </a:defRPr>
+            </a:pPr>
+            <a:r>
+              <a:t>•  Integrated ONLYOFFICE document server and published full production repo to GitHub.</a:t>
             </a:r>
           </a:p>
         </p:txBody>

</xml_diff>

<commit_message>
feat(pitch-deck): integrate live UI screenshots for notebooks and agent into 14-slide executive deck
</commit_message>
<xml_diff>
--- a/docs/TuT_AI_Marketing_Pitch_Deck.pptx
+++ b/docs/TuT_AI_Marketing_Pitch_Deck.pptx
@@ -17,6 +17,8 @@
     <p:sldId id="265" r:id="rId16"/>
     <p:sldId id="266" r:id="rId17"/>
     <p:sldId id="267" r:id="rId18"/>
+    <p:sldId id="268" r:id="rId19"/>
+    <p:sldId id="269" r:id="rId20"/>
   </p:sldIdLst>
   <p:sldSz cx="12191695" cy="6858000" type="screen4x3"/>
   <p:notesSz cx="6858000" cy="9144000"/>
@@ -3361,7 +3363,7 @@
               </a:defRPr>
             </a:pPr>
             <a:r>
-              <a:t>EVOLUTION</a:t>
+              <a:t>ENGINEERING MILESTONES</a:t>
             </a:r>
           </a:p>
         </p:txBody>
@@ -3397,7 +3399,7 @@
               </a:defRPr>
             </a:pPr>
             <a:r>
-              <a:t>Strategic Future Roadmap: Expanding TuT AI</a:t>
+              <a:t>The Development Journey: 4 Evolutionary Phases</a:t>
             </a:r>
           </a:p>
         </p:txBody>
@@ -3454,6 +3456,112 @@
         <p:spPr>
           <a:xfrm>
             <a:off x="731520" y="1645920"/>
+            <a:ext cx="5212080" cy="2194560"/>
+          </a:xfrm>
+          <a:prstGeom prst="roundRect">
+            <a:avLst/>
+          </a:prstGeom>
+          <a:solidFill>
+            <a:srgbClr val="111827"/>
+          </a:solidFill>
+          <a:ln w="15240">
+            <a:solidFill>
+              <a:srgbClr val="D4AF37"/>
+            </a:solidFill>
+          </a:ln>
+        </p:spPr>
+        <p:style>
+          <a:lnRef idx="1">
+            <a:schemeClr val="accent1"/>
+          </a:lnRef>
+          <a:fillRef idx="3">
+            <a:schemeClr val="accent1"/>
+          </a:fillRef>
+          <a:effectRef idx="2">
+            <a:schemeClr val="accent1"/>
+          </a:effectRef>
+          <a:fontRef idx="minor">
+            <a:schemeClr val="lt1"/>
+          </a:fontRef>
+        </p:style>
+        <p:txBody>
+          <a:bodyPr rtlCol="0" anchor="ctr" wrap="square" lIns="228600" rIns="228600" tIns="228600" bIns="182880"/>
+          <a:lstStyle/>
+          <a:p>
+            <a:pPr algn="ctr">
+              <a:spcAft>
+                <a:spcPts val="400"/>
+              </a:spcAft>
+              <a:defRPr sz="1000" b="1">
+                <a:solidFill>
+                  <a:srgbClr val="D4AF37"/>
+                </a:solidFill>
+                <a:latin typeface="Arial"/>
+              </a:defRPr>
+            </a:pPr>
+            <a:r>
+              <a:t>PHASE 1: INCEPTION</a:t>
+            </a:r>
+          </a:p>
+          <a:p>
+            <a:pPr>
+              <a:spcAft>
+                <a:spcPts val="1000"/>
+              </a:spcAft>
+              <a:defRPr sz="1600" b="1">
+                <a:solidFill>
+                  <a:srgbClr val="F8FAFC"/>
+                </a:solidFill>
+                <a:latin typeface="Arial"/>
+              </a:defRPr>
+            </a:pPr>
+            <a:r>
+              <a:t>Phase 1: Foundation &amp; Sovereign Identity</a:t>
+            </a:r>
+          </a:p>
+          <a:p>
+            <a:pPr>
+              <a:spcAft>
+                <a:spcPts val="600"/>
+              </a:spcAft>
+              <a:defRPr sz="1200">
+                <a:solidFill>
+                  <a:srgbClr val="94A3B8"/>
+                </a:solidFill>
+                <a:latin typeface="Arial"/>
+              </a:defRPr>
+            </a:pPr>
+            <a:r>
+              <a:t>•  Transitioned away from generic third-party code to 100% Egyptian sovereign platform.</a:t>
+            </a:r>
+          </a:p>
+          <a:p>
+            <a:pPr>
+              <a:spcAft>
+                <a:spcPts val="600"/>
+              </a:spcAft>
+              <a:defRPr sz="1200">
+                <a:solidFill>
+                  <a:srgbClr val="94A3B8"/>
+                </a:solidFill>
+                <a:latin typeface="Arial"/>
+              </a:defRPr>
+            </a:pPr>
+            <a:r>
+              <a:t>•  Engineered the TuT AI identity: 10 historical personas &amp; 3D holographic cartouche.</a:t>
+            </a:r>
+          </a:p>
+        </p:txBody>
+      </p:sp>
+      <p:sp>
+        <p:nvSpPr>
+          <p:cNvPr id="7" name="Rounded Rectangle 6"/>
+          <p:cNvSpPr/>
+          <p:nvPr/>
+        </p:nvSpPr>
+        <p:spPr>
+          <a:xfrm>
+            <a:off x="6217920" y="1645920"/>
             <a:ext cx="5212080" cy="2194560"/>
           </a:xfrm>
           <a:prstGeom prst="roundRect">
@@ -3498,7 +3606,7 @@
               </a:defRPr>
             </a:pPr>
             <a:r>
-              <a:t>SPEED</a:t>
+              <a:t>PHASE 2: ARCHITECTURE</a:t>
             </a:r>
           </a:p>
           <a:p>
@@ -3514,7 +3622,7 @@
               </a:defRPr>
             </a:pPr>
             <a:r>
-              <a:t>1. Ultra-Fast Inference via vLLM</a:t>
+              <a:t>Phase 2: Core Engines &amp; Resilient Fixes</a:t>
             </a:r>
           </a:p>
           <a:p>
@@ -3530,7 +3638,7 @@
               </a:defRPr>
             </a:pPr>
             <a:r>
-              <a:t>•  Integrate containerized vLLM with PagedAttention to achieve 60–80+ tokens/sec on RTX GPUs.</a:t>
+              <a:t>•  Engineered the 3 pillars: Deep Summarization, DeckCraft (.pptx), and VectorCraft (infographics).</a:t>
             </a:r>
           </a:p>
           <a:p>
@@ -3546,113 +3654,7 @@
               </a:defRPr>
             </a:pPr>
             <a:r>
-              <a:t>•  Support concurrent multi-user streaming for entire ministerial departments.</a:t>
-            </a:r>
-          </a:p>
-        </p:txBody>
-      </p:sp>
-      <p:sp>
-        <p:nvSpPr>
-          <p:cNvPr id="7" name="Rounded Rectangle 6"/>
-          <p:cNvSpPr/>
-          <p:nvPr/>
-        </p:nvSpPr>
-        <p:spPr>
-          <a:xfrm>
-            <a:off x="6217920" y="1645920"/>
-            <a:ext cx="5212080" cy="2194560"/>
-          </a:xfrm>
-          <a:prstGeom prst="roundRect">
-            <a:avLst/>
-          </a:prstGeom>
-          <a:solidFill>
-            <a:srgbClr val="111827"/>
-          </a:solidFill>
-          <a:ln w="15240">
-            <a:solidFill>
-              <a:srgbClr val="D4AF37"/>
-            </a:solidFill>
-          </a:ln>
-        </p:spPr>
-        <p:style>
-          <a:lnRef idx="1">
-            <a:schemeClr val="accent1"/>
-          </a:lnRef>
-          <a:fillRef idx="3">
-            <a:schemeClr val="accent1"/>
-          </a:fillRef>
-          <a:effectRef idx="2">
-            <a:schemeClr val="accent1"/>
-          </a:effectRef>
-          <a:fontRef idx="minor">
-            <a:schemeClr val="lt1"/>
-          </a:fontRef>
-        </p:style>
-        <p:txBody>
-          <a:bodyPr rtlCol="0" anchor="ctr" wrap="square" lIns="228600" rIns="228600" tIns="228600" bIns="182880"/>
-          <a:lstStyle/>
-          <a:p>
-            <a:pPr algn="ctr">
-              <a:spcAft>
-                <a:spcPts val="400"/>
-              </a:spcAft>
-              <a:defRPr sz="1000" b="1">
-                <a:solidFill>
-                  <a:srgbClr val="D4AF37"/>
-                </a:solidFill>
-                <a:latin typeface="Arial"/>
-              </a:defRPr>
-            </a:pPr>
-            <a:r>
-              <a:t>SPECIALIZATION</a:t>
-            </a:r>
-          </a:p>
-          <a:p>
-            <a:pPr>
-              <a:spcAft>
-                <a:spcPts val="1000"/>
-              </a:spcAft>
-              <a:defRPr sz="1600" b="1">
-                <a:solidFill>
-                  <a:srgbClr val="F8FAFC"/>
-                </a:solidFill>
-                <a:latin typeface="Arial"/>
-              </a:defRPr>
-            </a:pPr>
-            <a:r>
-              <a:t>2. Egyptian Governmental LoRA Fine-Tuning</a:t>
-            </a:r>
-          </a:p>
-          <a:p>
-            <a:pPr>
-              <a:spcAft>
-                <a:spcPts val="600"/>
-              </a:spcAft>
-              <a:defRPr sz="1200">
-                <a:solidFill>
-                  <a:srgbClr val="94A3B8"/>
-                </a:solidFill>
-                <a:latin typeface="Arial"/>
-              </a:defRPr>
-            </a:pPr>
-            <a:r>
-              <a:t>•  Fine-tune specialized LoRA adapters on official ministerial circulars, decrees, and laws.</a:t>
-            </a:r>
-          </a:p>
-          <a:p>
-            <a:pPr>
-              <a:spcAft>
-                <a:spcPts val="600"/>
-              </a:spcAft>
-              <a:defRPr sz="1200">
-                <a:solidFill>
-                  <a:srgbClr val="94A3B8"/>
-                </a:solidFill>
-                <a:latin typeface="Arial"/>
-              </a:defRPr>
-            </a:pPr>
-            <a:r>
-              <a:t>•  Guarantees 100% authentic Egyptian administrative protocol and terminology.</a:t>
+              <a:t>•  Resolved TRPC runtime crashes via intelligent local Ollama fallback proxy.</a:t>
             </a:r>
           </a:p>
         </p:txBody>
@@ -3710,7 +3712,7 @@
               </a:defRPr>
             </a:pPr>
             <a:r>
-              <a:t>VISION</a:t>
+              <a:t>PHASE 3: INTELLIGENCE</a:t>
             </a:r>
           </a:p>
           <a:p>
@@ -3726,7 +3728,7 @@
               </a:defRPr>
             </a:pPr>
             <a:r>
-              <a:t>3. Multimodal Vision for Scanned PDFs</a:t>
+              <a:t>Phase 3: Model Intelligence &amp; GPU Velocity</a:t>
             </a:r>
           </a:p>
           <a:p>
@@ -3742,7 +3744,7 @@
               </a:defRPr>
             </a:pPr>
             <a:r>
-              <a:t>•  Deploy Qwen2-VL or Llama-3.2-Vision to process historical Arabic manuscripts, stamps, and blueprints.</a:t>
+              <a:t>•  Unlocked database to 131,072 context tokens, 16,384 output tokens, and 'pro' reasoning.</a:t>
             </a:r>
           </a:p>
           <a:p>
@@ -3758,7 +3760,7 @@
               </a:defRPr>
             </a:pPr>
             <a:r>
-              <a:t>•  Direct table extraction from paper scans directly into Excel and charts.</a:t>
+              <a:t>•  Pinned gemma4:e4b into NVIDIA RTX 4050 GPU VRAM (keep_alive: '-1') for instant streaming.</a:t>
             </a:r>
           </a:p>
         </p:txBody>
@@ -3816,7 +3818,7 @@
               </a:defRPr>
             </a:pPr>
             <a:r>
-              <a:t>MULTI-AGENT</a:t>
+              <a:t>PHASE 4: PRODUCTION</a:t>
             </a:r>
           </a:p>
           <a:p>
@@ -3832,7 +3834,7 @@
               </a:defRPr>
             </a:pPr>
             <a:r>
-              <a:t>4. Autonomous Multi-Agent Swarms</a:t>
+              <a:t>Phase 4: Turnkey Production &amp; GitHub Release</a:t>
             </a:r>
           </a:p>
           <a:p>
@@ -3848,7 +3850,7 @@
               </a:defRPr>
             </a:pPr>
             <a:r>
-              <a:t>•  Autonomous delegation: Thoth researches, Imhotep audits data, and TuT delivers the final slides.</a:t>
+              <a:t>•  Built self-healing Docker architecture and turnkey 1-click setup scripts (.ps1 and .sh).</a:t>
             </a:r>
           </a:p>
           <a:p>
@@ -3864,7 +3866,7 @@
               </a:defRPr>
             </a:pPr>
             <a:r>
-              <a:t>•  Zero human micromanagement on complex multi-step state projects.</a:t>
+              <a:t>•  Integrated ONLYOFFICE document server and published full production repo to GitHub.</a:t>
             </a:r>
           </a:p>
         </p:txBody>
@@ -3961,7 +3963,7 @@
               </a:defRPr>
             </a:pPr>
             <a:r>
-              <a:t>PEOPLE &amp; GOVERNANCE</a:t>
+              <a:t>INSTITUTIONAL VALUE</a:t>
             </a:r>
           </a:p>
         </p:txBody>
@@ -3997,7 +3999,7 @@
               </a:defRPr>
             </a:pPr>
             <a:r>
-              <a:t>Project Leadership &amp; Development Team</a:t>
+              <a:t>Strategic &amp; Economic Impact for MCIT &amp; Government</a:t>
             </a:r>
           </a:p>
         </p:txBody>
@@ -4054,7 +4056,7 @@
         <p:spPr>
           <a:xfrm>
             <a:off x="731520" y="1645920"/>
-            <a:ext cx="5212080" cy="4572000"/>
+            <a:ext cx="3383280" cy="4572000"/>
           </a:xfrm>
           <a:prstGeom prst="roundRect">
             <a:avLst/>
@@ -4062,9 +4064,9 @@
           <a:solidFill>
             <a:srgbClr val="111827"/>
           </a:solidFill>
-          <a:ln w="19050">
+          <a:ln w="15240">
             <a:solidFill>
-              <a:srgbClr val="D4AF37"/>
+              <a:srgbClr val="34D399"/>
             </a:solidFill>
           </a:ln>
         </p:spPr>
@@ -4083,30 +4085,30 @@
           </a:fontRef>
         </p:style>
         <p:txBody>
-          <a:bodyPr rtlCol="0" anchor="ctr" wrap="square" lIns="274320" tIns="274320"/>
+          <a:bodyPr rtlCol="0" anchor="ctr" wrap="square" lIns="228600" rIns="228600" tIns="228600" bIns="182880"/>
           <a:lstStyle/>
           <a:p>
             <a:pPr algn="ctr">
               <a:spcAft>
-                <a:spcPts val="800"/>
-              </a:spcAft>
-              <a:defRPr sz="1100" b="1">
-                <a:solidFill>
-                  <a:srgbClr val="D4AF37"/>
-                </a:solidFill>
-                <a:latin typeface="Arial"/>
-              </a:defRPr>
-            </a:pPr>
-            <a:r>
-              <a:t>MINISTRY HEADS &amp; SUPERVISION</a:t>
-            </a:r>
-          </a:p>
-          <a:p>
-            <a:pPr>
-              <a:spcAft>
-                <a:spcPts val="1800"/>
-              </a:spcAft>
-              <a:defRPr sz="1800" b="1">
+                <a:spcPts val="400"/>
+              </a:spcAft>
+              <a:defRPr sz="1000" b="1">
+                <a:solidFill>
+                  <a:srgbClr val="34D399"/>
+                </a:solidFill>
+                <a:latin typeface="Arial"/>
+              </a:defRPr>
+            </a:pPr>
+            <a:r>
+              <a:t>SOVEREIGNTY</a:t>
+            </a:r>
+          </a:p>
+          <a:p>
+            <a:pPr>
+              <a:spcAft>
+                <a:spcPts val="1000"/>
+              </a:spcAft>
+              <a:defRPr sz="1600" b="1">
                 <a:solidFill>
                   <a:srgbClr val="F8FAFC"/>
                 </a:solidFill>
@@ -4114,55 +4116,71 @@
               </a:defRPr>
             </a:pPr>
             <a:r>
-              <a:t>Ministry Leadership &amp; Guidance</a:t>
-            </a:r>
-          </a:p>
-          <a:p>
-            <a:pPr>
-              <a:spcAft>
-                <a:spcPts val="2000"/>
-              </a:spcAft>
-              <a:defRPr sz="1500" b="1">
-                <a:solidFill>
-                  <a:srgbClr val="F5D673"/>
-                </a:solidFill>
-                <a:latin typeface="Arial"/>
-              </a:defRPr>
-            </a:pPr>
-            <a:r>
-              <a:t>🎖️  Dr. Mohamed Rehan</a:t>
-            </a:r>
-          </a:p>
-          <a:p>
-            <a:pPr>
-              <a:spcAft>
-                <a:spcPts val="2000"/>
-              </a:spcAft>
-              <a:defRPr sz="1500" b="1">
-                <a:solidFill>
-                  <a:srgbClr val="F5D673"/>
-                </a:solidFill>
-                <a:latin typeface="Arial"/>
-              </a:defRPr>
-            </a:pPr>
-            <a:r>
-              <a:t>🎖️  Eng. Reham Metwally</a:t>
-            </a:r>
-          </a:p>
-          <a:p>
-            <a:pPr>
-              <a:spcAft>
-                <a:spcPts val="2000"/>
-              </a:spcAft>
-              <a:defRPr sz="1500" b="1">
-                <a:solidFill>
-                  <a:srgbClr val="F5D673"/>
-                </a:solidFill>
-                <a:latin typeface="Arial"/>
-              </a:defRPr>
-            </a:pPr>
-            <a:r>
-              <a:t>🎖️  Eng. Mohamed Khalid Mohamed Roshdy</a:t>
+              <a:t>100% Data Sovereignty</a:t>
+            </a:r>
+          </a:p>
+          <a:p>
+            <a:pPr>
+              <a:spcAft>
+                <a:spcPts val="600"/>
+              </a:spcAft>
+              <a:defRPr sz="1200">
+                <a:solidFill>
+                  <a:srgbClr val="94A3B8"/>
+                </a:solidFill>
+                <a:latin typeface="Arial"/>
+              </a:defRPr>
+            </a:pPr>
+            <a:r>
+              <a:t>•  Zero cloud leakage: Classified ministerial files remain within the state firewall.</a:t>
+            </a:r>
+          </a:p>
+          <a:p>
+            <a:pPr>
+              <a:spcAft>
+                <a:spcPts val="600"/>
+              </a:spcAft>
+              <a:defRPr sz="1200">
+                <a:solidFill>
+                  <a:srgbClr val="94A3B8"/>
+                </a:solidFill>
+                <a:latin typeface="Arial"/>
+              </a:defRPr>
+            </a:pPr>
+            <a:r>
+              <a:t>•  Full compliance with national cybersecurity and data protection frameworks.</a:t>
+            </a:r>
+          </a:p>
+          <a:p>
+            <a:pPr>
+              <a:spcAft>
+                <a:spcPts val="600"/>
+              </a:spcAft>
+              <a:defRPr sz="1200">
+                <a:solidFill>
+                  <a:srgbClr val="94A3B8"/>
+                </a:solidFill>
+                <a:latin typeface="Arial"/>
+              </a:defRPr>
+            </a:pPr>
+            <a:r>
+              <a:t>•  Immune to foreign sanctions, cloud pricing hikes, or global connection blackouts.</a:t>
+            </a:r>
+          </a:p>
+          <a:p>
+            <a:pPr>
+              <a:spcAft>
+                <a:spcPts val="600"/>
+              </a:spcAft>
+              <a:defRPr sz="1200">
+                <a:solidFill>
+                  <a:srgbClr val="94A3B8"/>
+                </a:solidFill>
+                <a:latin typeface="Arial"/>
+              </a:defRPr>
+            </a:pPr>
+            <a:r>
+              <a:t>•  Total ownership of code, weights, data, and fine-tuned domain models.</a:t>
             </a:r>
           </a:p>
         </p:txBody>
@@ -4175,8 +4193,8 @@
         </p:nvSpPr>
         <p:spPr>
           <a:xfrm>
-            <a:off x="6217920" y="1645920"/>
-            <a:ext cx="5212080" cy="4572000"/>
+            <a:off x="4389120" y="1645920"/>
+            <a:ext cx="3383280" cy="4572000"/>
           </a:xfrm>
           <a:prstGeom prst="roundRect">
             <a:avLst/>
@@ -4184,9 +4202,9 @@
           <a:solidFill>
             <a:srgbClr val="111827"/>
           </a:solidFill>
-          <a:ln w="19050">
+          <a:ln w="15240">
             <a:solidFill>
-              <a:srgbClr val="38BDF8"/>
+              <a:srgbClr val="D4AF37"/>
             </a:solidFill>
           </a:ln>
         </p:spPr>
@@ -4205,14 +4223,152 @@
           </a:fontRef>
         </p:style>
         <p:txBody>
-          <a:bodyPr rtlCol="0" anchor="ctr" wrap="square" lIns="274320" tIns="274320"/>
+          <a:bodyPr rtlCol="0" anchor="ctr" wrap="square" lIns="228600" rIns="228600" tIns="228600" bIns="182880"/>
           <a:lstStyle/>
           <a:p>
             <a:pPr algn="ctr">
               <a:spcAft>
-                <a:spcPts val="800"/>
-              </a:spcAft>
-              <a:defRPr sz="1100" b="1">
+                <a:spcPts val="400"/>
+              </a:spcAft>
+              <a:defRPr sz="1000" b="1">
+                <a:solidFill>
+                  <a:srgbClr val="D4AF37"/>
+                </a:solidFill>
+                <a:latin typeface="Arial"/>
+              </a:defRPr>
+            </a:pPr>
+            <a:r>
+              <a:t>PRODUCTIVITY</a:t>
+            </a:r>
+          </a:p>
+          <a:p>
+            <a:pPr>
+              <a:spcAft>
+                <a:spcPts val="1000"/>
+              </a:spcAft>
+              <a:defRPr sz="1600" b="1">
+                <a:solidFill>
+                  <a:srgbClr val="F8FAFC"/>
+                </a:solidFill>
+                <a:latin typeface="Arial"/>
+              </a:defRPr>
+            </a:pPr>
+            <a:r>
+              <a:t>10x Operational Speed</a:t>
+            </a:r>
+          </a:p>
+          <a:p>
+            <a:pPr>
+              <a:spcAft>
+                <a:spcPts val="600"/>
+              </a:spcAft>
+              <a:defRPr sz="1200">
+                <a:solidFill>
+                  <a:srgbClr val="94A3B8"/>
+                </a:solidFill>
+                <a:latin typeface="Arial"/>
+              </a:defRPr>
+            </a:pPr>
+            <a:r>
+              <a:t>•  Reduces 4-hour document reading to a 30-second verified executive summary.</a:t>
+            </a:r>
+          </a:p>
+          <a:p>
+            <a:pPr>
+              <a:spcAft>
+                <a:spcPts val="600"/>
+              </a:spcAft>
+              <a:defRPr sz="1200">
+                <a:solidFill>
+                  <a:srgbClr val="94A3B8"/>
+                </a:solidFill>
+                <a:latin typeface="Arial"/>
+              </a:defRPr>
+            </a:pPr>
+            <a:r>
+              <a:t>•  Eliminates external design delays: Generates ready-to-present PowerPoint decks on demand.</a:t>
+            </a:r>
+          </a:p>
+          <a:p>
+            <a:pPr>
+              <a:spcAft>
+                <a:spcPts val="600"/>
+              </a:spcAft>
+              <a:defRPr sz="1200">
+                <a:solidFill>
+                  <a:srgbClr val="94A3B8"/>
+                </a:solidFill>
+                <a:latin typeface="Arial"/>
+              </a:defRPr>
+            </a:pPr>
+            <a:r>
+              <a:t>•  Instant ONLYOFFICE co-editing: Staff collaborate inside the platform without license costs.</a:t>
+            </a:r>
+          </a:p>
+          <a:p>
+            <a:pPr>
+              <a:spcAft>
+                <a:spcPts val="600"/>
+              </a:spcAft>
+              <a:defRPr sz="1200">
+                <a:solidFill>
+                  <a:srgbClr val="94A3B8"/>
+                </a:solidFill>
+                <a:latin typeface="Arial"/>
+              </a:defRPr>
+            </a:pPr>
+            <a:r>
+              <a:t>•  Empowers leadership with real-time strategic briefs during meetings.</a:t>
+            </a:r>
+          </a:p>
+        </p:txBody>
+      </p:sp>
+      <p:sp>
+        <p:nvSpPr>
+          <p:cNvPr id="8" name="Rounded Rectangle 7"/>
+          <p:cNvSpPr/>
+          <p:nvPr/>
+        </p:nvSpPr>
+        <p:spPr>
+          <a:xfrm>
+            <a:off x="8046720" y="1645920"/>
+            <a:ext cx="3383280" cy="4572000"/>
+          </a:xfrm>
+          <a:prstGeom prst="roundRect">
+            <a:avLst/>
+          </a:prstGeom>
+          <a:solidFill>
+            <a:srgbClr val="111827"/>
+          </a:solidFill>
+          <a:ln w="15240">
+            <a:solidFill>
+              <a:srgbClr val="38BDF8"/>
+            </a:solidFill>
+          </a:ln>
+        </p:spPr>
+        <p:style>
+          <a:lnRef idx="1">
+            <a:schemeClr val="accent1"/>
+          </a:lnRef>
+          <a:fillRef idx="3">
+            <a:schemeClr val="accent1"/>
+          </a:fillRef>
+          <a:effectRef idx="2">
+            <a:schemeClr val="accent1"/>
+          </a:effectRef>
+          <a:fontRef idx="minor">
+            <a:schemeClr val="lt1"/>
+          </a:fontRef>
+        </p:style>
+        <p:txBody>
+          <a:bodyPr rtlCol="0" anchor="ctr" wrap="square" lIns="228600" rIns="228600" tIns="228600" bIns="182880"/>
+          <a:lstStyle/>
+          <a:p>
+            <a:pPr algn="ctr">
+              <a:spcAft>
+                <a:spcPts val="400"/>
+              </a:spcAft>
+              <a:defRPr sz="1000" b="1">
                 <a:solidFill>
                   <a:srgbClr val="38BDF8"/>
                 </a:solidFill>
@@ -4220,15 +4376,15 @@
               </a:defRPr>
             </a:pPr>
             <a:r>
-              <a:t>ENGINEERING &amp; DEVELOPMENT TEAM</a:t>
-            </a:r>
-          </a:p>
-          <a:p>
-            <a:pPr>
-              <a:spcAft>
-                <a:spcPts val="1600"/>
-              </a:spcAft>
-              <a:defRPr sz="1800" b="1">
+              <a:t>COST EFFICIENCY</a:t>
+            </a:r>
+          </a:p>
+          <a:p>
+            <a:pPr>
+              <a:spcAft>
+                <a:spcPts val="1000"/>
+              </a:spcAft>
+              <a:defRPr sz="1600" b="1">
                 <a:solidFill>
                   <a:srgbClr val="F8FAFC"/>
                 </a:solidFill>
@@ -4236,103 +4392,71 @@
               </a:defRPr>
             </a:pPr>
             <a:r>
-              <a:t>TuT AI Core Team</a:t>
-            </a:r>
-          </a:p>
-          <a:p>
-            <a:pPr>
-              <a:spcAft>
-                <a:spcPts val="1200"/>
-              </a:spcAft>
-              <a:defRPr sz="1400" b="1">
-                <a:solidFill>
-                  <a:srgbClr val="D4AF37"/>
-                </a:solidFill>
-                <a:latin typeface="Arial"/>
-              </a:defRPr>
-            </a:pPr>
-            <a:r>
-              <a:t>⭐  Ahmed Gamal Sophi Arfa</a:t>
-            </a:r>
-          </a:p>
-          <a:p>
-            <a:pPr>
-              <a:spcAft>
-                <a:spcPts val="800"/>
-              </a:spcAft>
-              <a:defRPr sz="1300" b="1">
-                <a:solidFill>
-                  <a:srgbClr val="F8FAFC"/>
-                </a:solidFill>
-                <a:latin typeface="Arial"/>
-              </a:defRPr>
-            </a:pPr>
-            <a:r>
-              <a:t>•  Abdelrhman Mahmoud Fawzy</a:t>
-            </a:r>
-          </a:p>
-          <a:p>
-            <a:pPr>
-              <a:spcAft>
-                <a:spcPts val="800"/>
-              </a:spcAft>
-              <a:defRPr sz="1300" b="1">
-                <a:solidFill>
-                  <a:srgbClr val="F8FAFC"/>
-                </a:solidFill>
-                <a:latin typeface="Arial"/>
-              </a:defRPr>
-            </a:pPr>
-            <a:r>
-              <a:t>•  Saja Raafat Gaber</a:t>
-            </a:r>
-          </a:p>
-          <a:p>
-            <a:pPr>
-              <a:spcAft>
-                <a:spcPts val="800"/>
-              </a:spcAft>
-              <a:defRPr sz="1300" b="1">
-                <a:solidFill>
-                  <a:srgbClr val="F8FAFC"/>
-                </a:solidFill>
-                <a:latin typeface="Arial"/>
-              </a:defRPr>
-            </a:pPr>
-            <a:r>
-              <a:t>•  Mohamed Hamdy Abdelazez</a:t>
-            </a:r>
-          </a:p>
-          <a:p>
-            <a:pPr>
-              <a:spcAft>
-                <a:spcPts val="800"/>
-              </a:spcAft>
-              <a:defRPr sz="1300" b="1">
-                <a:solidFill>
-                  <a:srgbClr val="F8FAFC"/>
-                </a:solidFill>
-                <a:latin typeface="Arial"/>
-              </a:defRPr>
-            </a:pPr>
-            <a:r>
-              <a:t>•  Asmaa Samy Hagag</a:t>
-            </a:r>
-          </a:p>
-          <a:p>
-            <a:pPr>
-              <a:spcAft>
-                <a:spcPts val="800"/>
-              </a:spcAft>
-              <a:defRPr sz="1300" b="1">
-                <a:solidFill>
-                  <a:srgbClr val="F8FAFC"/>
-                </a:solidFill>
-                <a:latin typeface="Arial"/>
-              </a:defRPr>
-            </a:pPr>
-            <a:r>
-              <a:t>•  Mohamed Abd elhgani el kwatihy</a:t>
+              <a:t>Zero Recurring SaaS Costs</a:t>
+            </a:r>
+          </a:p>
+          <a:p>
+            <a:pPr>
+              <a:spcAft>
+                <a:spcPts val="600"/>
+              </a:spcAft>
+              <a:defRPr sz="1200">
+                <a:solidFill>
+                  <a:srgbClr val="94A3B8"/>
+                </a:solidFill>
+                <a:latin typeface="Arial"/>
+              </a:defRPr>
+            </a:pPr>
+            <a:r>
+              <a:t>•  No per-seat licensing fees (saving thousands of dollars annually on Copilot / ChatGPT Plus).</a:t>
+            </a:r>
+          </a:p>
+          <a:p>
+            <a:pPr>
+              <a:spcAft>
+                <a:spcPts val="600"/>
+              </a:spcAft>
+              <a:defRPr sz="1200">
+                <a:solidFill>
+                  <a:srgbClr val="94A3B8"/>
+                </a:solidFill>
+                <a:latin typeface="Arial"/>
+              </a:defRPr>
+            </a:pPr>
+            <a:r>
+              <a:t>•  Runs on existing departmental GPUs and workstations without expensive cloud clusters.</a:t>
+            </a:r>
+          </a:p>
+          <a:p>
+            <a:pPr>
+              <a:spcAft>
+                <a:spcPts val="600"/>
+              </a:spcAft>
+              <a:defRPr sz="1200">
+                <a:solidFill>
+                  <a:srgbClr val="94A3B8"/>
+                </a:solidFill>
+                <a:latin typeface="Arial"/>
+              </a:defRPr>
+            </a:pPr>
+            <a:r>
+              <a:t>•  Built on robust open-source foundations (SurrealDB, ParadeDB, Next.js, Fastify).</a:t>
+            </a:r>
+          </a:p>
+          <a:p>
+            <a:pPr>
+              <a:spcAft>
+                <a:spcPts val="600"/>
+              </a:spcAft>
+              <a:defRPr sz="1200">
+                <a:solidFill>
+                  <a:srgbClr val="94A3B8"/>
+                </a:solidFill>
+                <a:latin typeface="Arial"/>
+              </a:defRPr>
+            </a:pPr>
+            <a:r>
+              <a:t>•  Future-proof modularity: swap underlying open models seamlessly.</a:t>
             </a:r>
           </a:p>
         </p:txBody>
@@ -4406,6 +4530,1074 @@
         </p:nvSpPr>
         <p:spPr>
           <a:xfrm>
+            <a:off x="731520" y="365760"/>
+            <a:ext cx="10698480" cy="365760"/>
+          </a:xfrm>
+          <a:prstGeom prst="rect">
+            <a:avLst/>
+          </a:prstGeom>
+          <a:noFill/>
+        </p:spPr>
+        <p:txBody>
+          <a:bodyPr wrap="square">
+            <a:spAutoFit/>
+          </a:bodyPr>
+          <a:lstStyle/>
+          <a:p>
+            <a:pPr>
+              <a:defRPr sz="1100" b="1">
+                <a:solidFill>
+                  <a:srgbClr val="D4AF37"/>
+                </a:solidFill>
+                <a:latin typeface="Arial"/>
+              </a:defRPr>
+            </a:pPr>
+            <a:r>
+              <a:t>EVOLUTION</a:t>
+            </a:r>
+          </a:p>
+        </p:txBody>
+      </p:sp>
+      <p:sp>
+        <p:nvSpPr>
+          <p:cNvPr id="4" name="TextBox 3"/>
+          <p:cNvSpPr txBox="1"/>
+          <p:nvPr/>
+        </p:nvSpPr>
+        <p:spPr>
+          <a:xfrm>
+            <a:off x="731520" y="685800"/>
+            <a:ext cx="10698480" cy="640080"/>
+          </a:xfrm>
+          <a:prstGeom prst="rect">
+            <a:avLst/>
+          </a:prstGeom>
+          <a:noFill/>
+        </p:spPr>
+        <p:txBody>
+          <a:bodyPr wrap="square">
+            <a:spAutoFit/>
+          </a:bodyPr>
+          <a:lstStyle/>
+          <a:p>
+            <a:pPr>
+              <a:defRPr sz="2400" b="1">
+                <a:solidFill>
+                  <a:srgbClr val="F8FAFC"/>
+                </a:solidFill>
+                <a:latin typeface="Arial"/>
+              </a:defRPr>
+            </a:pPr>
+            <a:r>
+              <a:t>Strategic Future Roadmap: Expanding TuT AI</a:t>
+            </a:r>
+          </a:p>
+        </p:txBody>
+      </p:sp>
+      <p:sp>
+        <p:nvSpPr>
+          <p:cNvPr id="5" name="Rectangle 4"/>
+          <p:cNvSpPr/>
+          <p:nvPr/>
+        </p:nvSpPr>
+        <p:spPr>
+          <a:xfrm>
+            <a:off x="731520" y="1371600"/>
+            <a:ext cx="10728655" cy="18288"/>
+          </a:xfrm>
+          <a:prstGeom prst="rect">
+            <a:avLst/>
+          </a:prstGeom>
+          <a:solidFill>
+            <a:srgbClr val="D4AF37"/>
+          </a:solidFill>
+          <a:ln>
+            <a:noFill/>
+          </a:ln>
+        </p:spPr>
+        <p:style>
+          <a:lnRef idx="1">
+            <a:schemeClr val="accent1"/>
+          </a:lnRef>
+          <a:fillRef idx="3">
+            <a:schemeClr val="accent1"/>
+          </a:fillRef>
+          <a:effectRef idx="2">
+            <a:schemeClr val="accent1"/>
+          </a:effectRef>
+          <a:fontRef idx="minor">
+            <a:schemeClr val="lt1"/>
+          </a:fontRef>
+        </p:style>
+        <p:txBody>
+          <a:bodyPr rtlCol="0" anchor="ctr"/>
+          <a:lstStyle/>
+          <a:p>
+            <a:pPr algn="ctr"/>
+          </a:p>
+        </p:txBody>
+      </p:sp>
+      <p:sp>
+        <p:nvSpPr>
+          <p:cNvPr id="6" name="Rounded Rectangle 5"/>
+          <p:cNvSpPr/>
+          <p:nvPr/>
+        </p:nvSpPr>
+        <p:spPr>
+          <a:xfrm>
+            <a:off x="731520" y="1645920"/>
+            <a:ext cx="5212080" cy="2194560"/>
+          </a:xfrm>
+          <a:prstGeom prst="roundRect">
+            <a:avLst/>
+          </a:prstGeom>
+          <a:solidFill>
+            <a:srgbClr val="111827"/>
+          </a:solidFill>
+          <a:ln w="15240">
+            <a:solidFill>
+              <a:srgbClr val="38BDF8"/>
+            </a:solidFill>
+          </a:ln>
+        </p:spPr>
+        <p:style>
+          <a:lnRef idx="1">
+            <a:schemeClr val="accent1"/>
+          </a:lnRef>
+          <a:fillRef idx="3">
+            <a:schemeClr val="accent1"/>
+          </a:fillRef>
+          <a:effectRef idx="2">
+            <a:schemeClr val="accent1"/>
+          </a:effectRef>
+          <a:fontRef idx="minor">
+            <a:schemeClr val="lt1"/>
+          </a:fontRef>
+        </p:style>
+        <p:txBody>
+          <a:bodyPr rtlCol="0" anchor="ctr" wrap="square" lIns="228600" rIns="228600" tIns="228600" bIns="182880"/>
+          <a:lstStyle/>
+          <a:p>
+            <a:pPr algn="ctr">
+              <a:spcAft>
+                <a:spcPts val="400"/>
+              </a:spcAft>
+              <a:defRPr sz="1000" b="1">
+                <a:solidFill>
+                  <a:srgbClr val="38BDF8"/>
+                </a:solidFill>
+                <a:latin typeface="Arial"/>
+              </a:defRPr>
+            </a:pPr>
+            <a:r>
+              <a:t>SPEED</a:t>
+            </a:r>
+          </a:p>
+          <a:p>
+            <a:pPr>
+              <a:spcAft>
+                <a:spcPts val="1000"/>
+              </a:spcAft>
+              <a:defRPr sz="1600" b="1">
+                <a:solidFill>
+                  <a:srgbClr val="F8FAFC"/>
+                </a:solidFill>
+                <a:latin typeface="Arial"/>
+              </a:defRPr>
+            </a:pPr>
+            <a:r>
+              <a:t>1. Ultra-Fast Inference via vLLM</a:t>
+            </a:r>
+          </a:p>
+          <a:p>
+            <a:pPr>
+              <a:spcAft>
+                <a:spcPts val="600"/>
+              </a:spcAft>
+              <a:defRPr sz="1200">
+                <a:solidFill>
+                  <a:srgbClr val="94A3B8"/>
+                </a:solidFill>
+                <a:latin typeface="Arial"/>
+              </a:defRPr>
+            </a:pPr>
+            <a:r>
+              <a:t>•  Integrate containerized vLLM with PagedAttention to achieve 60–80+ tokens/sec on RTX GPUs.</a:t>
+            </a:r>
+          </a:p>
+          <a:p>
+            <a:pPr>
+              <a:spcAft>
+                <a:spcPts val="600"/>
+              </a:spcAft>
+              <a:defRPr sz="1200">
+                <a:solidFill>
+                  <a:srgbClr val="94A3B8"/>
+                </a:solidFill>
+                <a:latin typeface="Arial"/>
+              </a:defRPr>
+            </a:pPr>
+            <a:r>
+              <a:t>•  Support concurrent multi-user streaming for entire ministerial departments.</a:t>
+            </a:r>
+          </a:p>
+        </p:txBody>
+      </p:sp>
+      <p:sp>
+        <p:nvSpPr>
+          <p:cNvPr id="7" name="Rounded Rectangle 6"/>
+          <p:cNvSpPr/>
+          <p:nvPr/>
+        </p:nvSpPr>
+        <p:spPr>
+          <a:xfrm>
+            <a:off x="6217920" y="1645920"/>
+            <a:ext cx="5212080" cy="2194560"/>
+          </a:xfrm>
+          <a:prstGeom prst="roundRect">
+            <a:avLst/>
+          </a:prstGeom>
+          <a:solidFill>
+            <a:srgbClr val="111827"/>
+          </a:solidFill>
+          <a:ln w="15240">
+            <a:solidFill>
+              <a:srgbClr val="D4AF37"/>
+            </a:solidFill>
+          </a:ln>
+        </p:spPr>
+        <p:style>
+          <a:lnRef idx="1">
+            <a:schemeClr val="accent1"/>
+          </a:lnRef>
+          <a:fillRef idx="3">
+            <a:schemeClr val="accent1"/>
+          </a:fillRef>
+          <a:effectRef idx="2">
+            <a:schemeClr val="accent1"/>
+          </a:effectRef>
+          <a:fontRef idx="minor">
+            <a:schemeClr val="lt1"/>
+          </a:fontRef>
+        </p:style>
+        <p:txBody>
+          <a:bodyPr rtlCol="0" anchor="ctr" wrap="square" lIns="228600" rIns="228600" tIns="228600" bIns="182880"/>
+          <a:lstStyle/>
+          <a:p>
+            <a:pPr algn="ctr">
+              <a:spcAft>
+                <a:spcPts val="400"/>
+              </a:spcAft>
+              <a:defRPr sz="1000" b="1">
+                <a:solidFill>
+                  <a:srgbClr val="D4AF37"/>
+                </a:solidFill>
+                <a:latin typeface="Arial"/>
+              </a:defRPr>
+            </a:pPr>
+            <a:r>
+              <a:t>SPECIALIZATION</a:t>
+            </a:r>
+          </a:p>
+          <a:p>
+            <a:pPr>
+              <a:spcAft>
+                <a:spcPts val="1000"/>
+              </a:spcAft>
+              <a:defRPr sz="1600" b="1">
+                <a:solidFill>
+                  <a:srgbClr val="F8FAFC"/>
+                </a:solidFill>
+                <a:latin typeface="Arial"/>
+              </a:defRPr>
+            </a:pPr>
+            <a:r>
+              <a:t>2. Egyptian Governmental LoRA Fine-Tuning</a:t>
+            </a:r>
+          </a:p>
+          <a:p>
+            <a:pPr>
+              <a:spcAft>
+                <a:spcPts val="600"/>
+              </a:spcAft>
+              <a:defRPr sz="1200">
+                <a:solidFill>
+                  <a:srgbClr val="94A3B8"/>
+                </a:solidFill>
+                <a:latin typeface="Arial"/>
+              </a:defRPr>
+            </a:pPr>
+            <a:r>
+              <a:t>•  Fine-tune specialized LoRA adapters on official ministerial circulars, decrees, and laws.</a:t>
+            </a:r>
+          </a:p>
+          <a:p>
+            <a:pPr>
+              <a:spcAft>
+                <a:spcPts val="600"/>
+              </a:spcAft>
+              <a:defRPr sz="1200">
+                <a:solidFill>
+                  <a:srgbClr val="94A3B8"/>
+                </a:solidFill>
+                <a:latin typeface="Arial"/>
+              </a:defRPr>
+            </a:pPr>
+            <a:r>
+              <a:t>•  Guarantees 100% authentic Egyptian administrative protocol and terminology.</a:t>
+            </a:r>
+          </a:p>
+        </p:txBody>
+      </p:sp>
+      <p:sp>
+        <p:nvSpPr>
+          <p:cNvPr id="8" name="Rounded Rectangle 7"/>
+          <p:cNvSpPr/>
+          <p:nvPr/>
+        </p:nvSpPr>
+        <p:spPr>
+          <a:xfrm>
+            <a:off x="731520" y="4023360"/>
+            <a:ext cx="5212080" cy="2194560"/>
+          </a:xfrm>
+          <a:prstGeom prst="roundRect">
+            <a:avLst/>
+          </a:prstGeom>
+          <a:solidFill>
+            <a:srgbClr val="111827"/>
+          </a:solidFill>
+          <a:ln w="15240">
+            <a:solidFill>
+              <a:srgbClr val="34D399"/>
+            </a:solidFill>
+          </a:ln>
+        </p:spPr>
+        <p:style>
+          <a:lnRef idx="1">
+            <a:schemeClr val="accent1"/>
+          </a:lnRef>
+          <a:fillRef idx="3">
+            <a:schemeClr val="accent1"/>
+          </a:fillRef>
+          <a:effectRef idx="2">
+            <a:schemeClr val="accent1"/>
+          </a:effectRef>
+          <a:fontRef idx="minor">
+            <a:schemeClr val="lt1"/>
+          </a:fontRef>
+        </p:style>
+        <p:txBody>
+          <a:bodyPr rtlCol="0" anchor="ctr" wrap="square" lIns="228600" rIns="228600" tIns="228600" bIns="182880"/>
+          <a:lstStyle/>
+          <a:p>
+            <a:pPr algn="ctr">
+              <a:spcAft>
+                <a:spcPts val="400"/>
+              </a:spcAft>
+              <a:defRPr sz="1000" b="1">
+                <a:solidFill>
+                  <a:srgbClr val="34D399"/>
+                </a:solidFill>
+                <a:latin typeface="Arial"/>
+              </a:defRPr>
+            </a:pPr>
+            <a:r>
+              <a:t>VISION</a:t>
+            </a:r>
+          </a:p>
+          <a:p>
+            <a:pPr>
+              <a:spcAft>
+                <a:spcPts val="1000"/>
+              </a:spcAft>
+              <a:defRPr sz="1600" b="1">
+                <a:solidFill>
+                  <a:srgbClr val="F8FAFC"/>
+                </a:solidFill>
+                <a:latin typeface="Arial"/>
+              </a:defRPr>
+            </a:pPr>
+            <a:r>
+              <a:t>3. Multimodal Vision for Scanned PDFs</a:t>
+            </a:r>
+          </a:p>
+          <a:p>
+            <a:pPr>
+              <a:spcAft>
+                <a:spcPts val="600"/>
+              </a:spcAft>
+              <a:defRPr sz="1200">
+                <a:solidFill>
+                  <a:srgbClr val="94A3B8"/>
+                </a:solidFill>
+                <a:latin typeface="Arial"/>
+              </a:defRPr>
+            </a:pPr>
+            <a:r>
+              <a:t>•  Deploy Qwen2-VL or Llama-3.2-Vision to process historical Arabic manuscripts, stamps, and blueprints.</a:t>
+            </a:r>
+          </a:p>
+          <a:p>
+            <a:pPr>
+              <a:spcAft>
+                <a:spcPts val="600"/>
+              </a:spcAft>
+              <a:defRPr sz="1200">
+                <a:solidFill>
+                  <a:srgbClr val="94A3B8"/>
+                </a:solidFill>
+                <a:latin typeface="Arial"/>
+              </a:defRPr>
+            </a:pPr>
+            <a:r>
+              <a:t>•  Direct table extraction from paper scans directly into Excel and charts.</a:t>
+            </a:r>
+          </a:p>
+        </p:txBody>
+      </p:sp>
+      <p:sp>
+        <p:nvSpPr>
+          <p:cNvPr id="9" name="Rounded Rectangle 8"/>
+          <p:cNvSpPr/>
+          <p:nvPr/>
+        </p:nvSpPr>
+        <p:spPr>
+          <a:xfrm>
+            <a:off x="6217920" y="4023360"/>
+            <a:ext cx="5212080" cy="2194560"/>
+          </a:xfrm>
+          <a:prstGeom prst="roundRect">
+            <a:avLst/>
+          </a:prstGeom>
+          <a:solidFill>
+            <a:srgbClr val="111827"/>
+          </a:solidFill>
+          <a:ln w="15240">
+            <a:solidFill>
+              <a:srgbClr val="F59E0B"/>
+            </a:solidFill>
+          </a:ln>
+        </p:spPr>
+        <p:style>
+          <a:lnRef idx="1">
+            <a:schemeClr val="accent1"/>
+          </a:lnRef>
+          <a:fillRef idx="3">
+            <a:schemeClr val="accent1"/>
+          </a:fillRef>
+          <a:effectRef idx="2">
+            <a:schemeClr val="accent1"/>
+          </a:effectRef>
+          <a:fontRef idx="minor">
+            <a:schemeClr val="lt1"/>
+          </a:fontRef>
+        </p:style>
+        <p:txBody>
+          <a:bodyPr rtlCol="0" anchor="ctr" wrap="square" lIns="228600" rIns="228600" tIns="228600" bIns="182880"/>
+          <a:lstStyle/>
+          <a:p>
+            <a:pPr algn="ctr">
+              <a:spcAft>
+                <a:spcPts val="400"/>
+              </a:spcAft>
+              <a:defRPr sz="1000" b="1">
+                <a:solidFill>
+                  <a:srgbClr val="F59E0B"/>
+                </a:solidFill>
+                <a:latin typeface="Arial"/>
+              </a:defRPr>
+            </a:pPr>
+            <a:r>
+              <a:t>MULTI-AGENT</a:t>
+            </a:r>
+          </a:p>
+          <a:p>
+            <a:pPr>
+              <a:spcAft>
+                <a:spcPts val="1000"/>
+              </a:spcAft>
+              <a:defRPr sz="1600" b="1">
+                <a:solidFill>
+                  <a:srgbClr val="F8FAFC"/>
+                </a:solidFill>
+                <a:latin typeface="Arial"/>
+              </a:defRPr>
+            </a:pPr>
+            <a:r>
+              <a:t>4. Autonomous Multi-Agent Swarms</a:t>
+            </a:r>
+          </a:p>
+          <a:p>
+            <a:pPr>
+              <a:spcAft>
+                <a:spcPts val="600"/>
+              </a:spcAft>
+              <a:defRPr sz="1200">
+                <a:solidFill>
+                  <a:srgbClr val="94A3B8"/>
+                </a:solidFill>
+                <a:latin typeface="Arial"/>
+              </a:defRPr>
+            </a:pPr>
+            <a:r>
+              <a:t>•  Autonomous delegation: Thoth researches, Imhotep audits data, and TuT delivers the final slides.</a:t>
+            </a:r>
+          </a:p>
+          <a:p>
+            <a:pPr>
+              <a:spcAft>
+                <a:spcPts val="600"/>
+              </a:spcAft>
+              <a:defRPr sz="1200">
+                <a:solidFill>
+                  <a:srgbClr val="94A3B8"/>
+                </a:solidFill>
+                <a:latin typeface="Arial"/>
+              </a:defRPr>
+            </a:pPr>
+            <a:r>
+              <a:t>•  Zero human micromanagement on complex multi-step state projects.</a:t>
+            </a:r>
+          </a:p>
+        </p:txBody>
+      </p:sp>
+    </p:spTree>
+  </p:cSld>
+  <p:clrMapOvr>
+    <a:masterClrMapping/>
+  </p:clrMapOvr>
+</p:sld>
+</file>
+
+<file path=ppt/slides/slide13.xml><?xml version="1.0" encoding="utf-8"?>
+<p:sld xmlns:a="http://schemas.openxmlformats.org/drawingml/2006/main" xmlns:p="http://schemas.openxmlformats.org/presentationml/2006/main" xmlns:r="http://schemas.openxmlformats.org/officeDocument/2006/relationships">
+  <p:cSld>
+    <p:spTree>
+      <p:nvGrpSpPr>
+        <p:cNvPr id="1" name=""/>
+        <p:cNvGrpSpPr/>
+        <p:nvPr/>
+      </p:nvGrpSpPr>
+      <p:grpSpPr/>
+      <p:sp>
+        <p:nvSpPr>
+          <p:cNvPr id="2" name="Rectangle 1"/>
+          <p:cNvSpPr/>
+          <p:nvPr/>
+        </p:nvSpPr>
+        <p:spPr>
+          <a:xfrm>
+            <a:off x="0" y="0"/>
+            <a:ext cx="12191695" cy="6858000"/>
+          </a:xfrm>
+          <a:prstGeom prst="rect">
+            <a:avLst/>
+          </a:prstGeom>
+          <a:solidFill>
+            <a:srgbClr val="0A0E17"/>
+          </a:solidFill>
+          <a:ln>
+            <a:noFill/>
+          </a:ln>
+        </p:spPr>
+        <p:style>
+          <a:lnRef idx="1">
+            <a:schemeClr val="accent1"/>
+          </a:lnRef>
+          <a:fillRef idx="3">
+            <a:schemeClr val="accent1"/>
+          </a:fillRef>
+          <a:effectRef idx="2">
+            <a:schemeClr val="accent1"/>
+          </a:effectRef>
+          <a:fontRef idx="minor">
+            <a:schemeClr val="lt1"/>
+          </a:fontRef>
+        </p:style>
+        <p:txBody>
+          <a:bodyPr rtlCol="0" anchor="ctr"/>
+          <a:lstStyle/>
+          <a:p>
+            <a:pPr algn="ctr"/>
+          </a:p>
+        </p:txBody>
+      </p:sp>
+      <p:sp>
+        <p:nvSpPr>
+          <p:cNvPr id="3" name="TextBox 2"/>
+          <p:cNvSpPr txBox="1"/>
+          <p:nvPr/>
+        </p:nvSpPr>
+        <p:spPr>
+          <a:xfrm>
+            <a:off x="731520" y="365760"/>
+            <a:ext cx="10698480" cy="365760"/>
+          </a:xfrm>
+          <a:prstGeom prst="rect">
+            <a:avLst/>
+          </a:prstGeom>
+          <a:noFill/>
+        </p:spPr>
+        <p:txBody>
+          <a:bodyPr wrap="square">
+            <a:spAutoFit/>
+          </a:bodyPr>
+          <a:lstStyle/>
+          <a:p>
+            <a:pPr>
+              <a:defRPr sz="1100" b="1">
+                <a:solidFill>
+                  <a:srgbClr val="D4AF37"/>
+                </a:solidFill>
+                <a:latin typeface="Arial"/>
+              </a:defRPr>
+            </a:pPr>
+            <a:r>
+              <a:t>PEOPLE &amp; GOVERNANCE</a:t>
+            </a:r>
+          </a:p>
+        </p:txBody>
+      </p:sp>
+      <p:sp>
+        <p:nvSpPr>
+          <p:cNvPr id="4" name="TextBox 3"/>
+          <p:cNvSpPr txBox="1"/>
+          <p:nvPr/>
+        </p:nvSpPr>
+        <p:spPr>
+          <a:xfrm>
+            <a:off x="731520" y="685800"/>
+            <a:ext cx="10698480" cy="640080"/>
+          </a:xfrm>
+          <a:prstGeom prst="rect">
+            <a:avLst/>
+          </a:prstGeom>
+          <a:noFill/>
+        </p:spPr>
+        <p:txBody>
+          <a:bodyPr wrap="square">
+            <a:spAutoFit/>
+          </a:bodyPr>
+          <a:lstStyle/>
+          <a:p>
+            <a:pPr>
+              <a:defRPr sz="2400" b="1">
+                <a:solidFill>
+                  <a:srgbClr val="F8FAFC"/>
+                </a:solidFill>
+                <a:latin typeface="Arial"/>
+              </a:defRPr>
+            </a:pPr>
+            <a:r>
+              <a:t>Project Leadership &amp; Development Team</a:t>
+            </a:r>
+          </a:p>
+        </p:txBody>
+      </p:sp>
+      <p:sp>
+        <p:nvSpPr>
+          <p:cNvPr id="5" name="Rectangle 4"/>
+          <p:cNvSpPr/>
+          <p:nvPr/>
+        </p:nvSpPr>
+        <p:spPr>
+          <a:xfrm>
+            <a:off x="731520" y="1371600"/>
+            <a:ext cx="10728655" cy="18288"/>
+          </a:xfrm>
+          <a:prstGeom prst="rect">
+            <a:avLst/>
+          </a:prstGeom>
+          <a:solidFill>
+            <a:srgbClr val="D4AF37"/>
+          </a:solidFill>
+          <a:ln>
+            <a:noFill/>
+          </a:ln>
+        </p:spPr>
+        <p:style>
+          <a:lnRef idx="1">
+            <a:schemeClr val="accent1"/>
+          </a:lnRef>
+          <a:fillRef idx="3">
+            <a:schemeClr val="accent1"/>
+          </a:fillRef>
+          <a:effectRef idx="2">
+            <a:schemeClr val="accent1"/>
+          </a:effectRef>
+          <a:fontRef idx="minor">
+            <a:schemeClr val="lt1"/>
+          </a:fontRef>
+        </p:style>
+        <p:txBody>
+          <a:bodyPr rtlCol="0" anchor="ctr"/>
+          <a:lstStyle/>
+          <a:p>
+            <a:pPr algn="ctr"/>
+          </a:p>
+        </p:txBody>
+      </p:sp>
+      <p:sp>
+        <p:nvSpPr>
+          <p:cNvPr id="6" name="Rounded Rectangle 5"/>
+          <p:cNvSpPr/>
+          <p:nvPr/>
+        </p:nvSpPr>
+        <p:spPr>
+          <a:xfrm>
+            <a:off x="731520" y="1645920"/>
+            <a:ext cx="5212080" cy="4572000"/>
+          </a:xfrm>
+          <a:prstGeom prst="roundRect">
+            <a:avLst/>
+          </a:prstGeom>
+          <a:solidFill>
+            <a:srgbClr val="111827"/>
+          </a:solidFill>
+          <a:ln w="19050">
+            <a:solidFill>
+              <a:srgbClr val="D4AF37"/>
+            </a:solidFill>
+          </a:ln>
+        </p:spPr>
+        <p:style>
+          <a:lnRef idx="1">
+            <a:schemeClr val="accent1"/>
+          </a:lnRef>
+          <a:fillRef idx="3">
+            <a:schemeClr val="accent1"/>
+          </a:fillRef>
+          <a:effectRef idx="2">
+            <a:schemeClr val="accent1"/>
+          </a:effectRef>
+          <a:fontRef idx="minor">
+            <a:schemeClr val="lt1"/>
+          </a:fontRef>
+        </p:style>
+        <p:txBody>
+          <a:bodyPr rtlCol="0" anchor="ctr" wrap="square" lIns="274320" tIns="274320"/>
+          <a:lstStyle/>
+          <a:p>
+            <a:pPr algn="ctr">
+              <a:spcAft>
+                <a:spcPts val="800"/>
+              </a:spcAft>
+              <a:defRPr sz="1100" b="1">
+                <a:solidFill>
+                  <a:srgbClr val="D4AF37"/>
+                </a:solidFill>
+                <a:latin typeface="Arial"/>
+              </a:defRPr>
+            </a:pPr>
+            <a:r>
+              <a:t>MINISTRY HEADS &amp; SUPERVISION</a:t>
+            </a:r>
+          </a:p>
+          <a:p>
+            <a:pPr>
+              <a:spcAft>
+                <a:spcPts val="1800"/>
+              </a:spcAft>
+              <a:defRPr sz="1800" b="1">
+                <a:solidFill>
+                  <a:srgbClr val="F8FAFC"/>
+                </a:solidFill>
+                <a:latin typeface="Arial"/>
+              </a:defRPr>
+            </a:pPr>
+            <a:r>
+              <a:t>Ministry Leadership &amp; Guidance</a:t>
+            </a:r>
+          </a:p>
+          <a:p>
+            <a:pPr>
+              <a:spcAft>
+                <a:spcPts val="2000"/>
+              </a:spcAft>
+              <a:defRPr sz="1500" b="1">
+                <a:solidFill>
+                  <a:srgbClr val="F5D673"/>
+                </a:solidFill>
+                <a:latin typeface="Arial"/>
+              </a:defRPr>
+            </a:pPr>
+            <a:r>
+              <a:t>🎖️  Dr. Mohamed Rehan</a:t>
+            </a:r>
+          </a:p>
+          <a:p>
+            <a:pPr>
+              <a:spcAft>
+                <a:spcPts val="2000"/>
+              </a:spcAft>
+              <a:defRPr sz="1500" b="1">
+                <a:solidFill>
+                  <a:srgbClr val="F5D673"/>
+                </a:solidFill>
+                <a:latin typeface="Arial"/>
+              </a:defRPr>
+            </a:pPr>
+            <a:r>
+              <a:t>🎖️  Eng. Reham Metwally</a:t>
+            </a:r>
+          </a:p>
+          <a:p>
+            <a:pPr>
+              <a:spcAft>
+                <a:spcPts val="2000"/>
+              </a:spcAft>
+              <a:defRPr sz="1500" b="1">
+                <a:solidFill>
+                  <a:srgbClr val="F5D673"/>
+                </a:solidFill>
+                <a:latin typeface="Arial"/>
+              </a:defRPr>
+            </a:pPr>
+            <a:r>
+              <a:t>🎖️  Eng. Mohamed Khalid Mohamed Roshdy</a:t>
+            </a:r>
+          </a:p>
+        </p:txBody>
+      </p:sp>
+      <p:sp>
+        <p:nvSpPr>
+          <p:cNvPr id="7" name="Rounded Rectangle 6"/>
+          <p:cNvSpPr/>
+          <p:nvPr/>
+        </p:nvSpPr>
+        <p:spPr>
+          <a:xfrm>
+            <a:off x="6217920" y="1645920"/>
+            <a:ext cx="5212080" cy="4572000"/>
+          </a:xfrm>
+          <a:prstGeom prst="roundRect">
+            <a:avLst/>
+          </a:prstGeom>
+          <a:solidFill>
+            <a:srgbClr val="111827"/>
+          </a:solidFill>
+          <a:ln w="19050">
+            <a:solidFill>
+              <a:srgbClr val="38BDF8"/>
+            </a:solidFill>
+          </a:ln>
+        </p:spPr>
+        <p:style>
+          <a:lnRef idx="1">
+            <a:schemeClr val="accent1"/>
+          </a:lnRef>
+          <a:fillRef idx="3">
+            <a:schemeClr val="accent1"/>
+          </a:fillRef>
+          <a:effectRef idx="2">
+            <a:schemeClr val="accent1"/>
+          </a:effectRef>
+          <a:fontRef idx="minor">
+            <a:schemeClr val="lt1"/>
+          </a:fontRef>
+        </p:style>
+        <p:txBody>
+          <a:bodyPr rtlCol="0" anchor="ctr" wrap="square" lIns="274320" tIns="274320"/>
+          <a:lstStyle/>
+          <a:p>
+            <a:pPr algn="ctr">
+              <a:spcAft>
+                <a:spcPts val="800"/>
+              </a:spcAft>
+              <a:defRPr sz="1100" b="1">
+                <a:solidFill>
+                  <a:srgbClr val="38BDF8"/>
+                </a:solidFill>
+                <a:latin typeface="Arial"/>
+              </a:defRPr>
+            </a:pPr>
+            <a:r>
+              <a:t>ENGINEERING &amp; DEVELOPMENT TEAM</a:t>
+            </a:r>
+          </a:p>
+          <a:p>
+            <a:pPr>
+              <a:spcAft>
+                <a:spcPts val="1600"/>
+              </a:spcAft>
+              <a:defRPr sz="1800" b="1">
+                <a:solidFill>
+                  <a:srgbClr val="F8FAFC"/>
+                </a:solidFill>
+                <a:latin typeface="Arial"/>
+              </a:defRPr>
+            </a:pPr>
+            <a:r>
+              <a:t>TuT AI Core Team</a:t>
+            </a:r>
+          </a:p>
+          <a:p>
+            <a:pPr>
+              <a:spcAft>
+                <a:spcPts val="1200"/>
+              </a:spcAft>
+              <a:defRPr sz="1400" b="1">
+                <a:solidFill>
+                  <a:srgbClr val="D4AF37"/>
+                </a:solidFill>
+                <a:latin typeface="Arial"/>
+              </a:defRPr>
+            </a:pPr>
+            <a:r>
+              <a:t>⭐  Ahmed Gamal Sophi Arfa</a:t>
+            </a:r>
+          </a:p>
+          <a:p>
+            <a:pPr>
+              <a:spcAft>
+                <a:spcPts val="800"/>
+              </a:spcAft>
+              <a:defRPr sz="1300" b="1">
+                <a:solidFill>
+                  <a:srgbClr val="F8FAFC"/>
+                </a:solidFill>
+                <a:latin typeface="Arial"/>
+              </a:defRPr>
+            </a:pPr>
+            <a:r>
+              <a:t>•  Abdelrhman Mahmoud Fawzy</a:t>
+            </a:r>
+          </a:p>
+          <a:p>
+            <a:pPr>
+              <a:spcAft>
+                <a:spcPts val="800"/>
+              </a:spcAft>
+              <a:defRPr sz="1300" b="1">
+                <a:solidFill>
+                  <a:srgbClr val="F8FAFC"/>
+                </a:solidFill>
+                <a:latin typeface="Arial"/>
+              </a:defRPr>
+            </a:pPr>
+            <a:r>
+              <a:t>•  Saja Raafat Gaber</a:t>
+            </a:r>
+          </a:p>
+          <a:p>
+            <a:pPr>
+              <a:spcAft>
+                <a:spcPts val="800"/>
+              </a:spcAft>
+              <a:defRPr sz="1300" b="1">
+                <a:solidFill>
+                  <a:srgbClr val="F8FAFC"/>
+                </a:solidFill>
+                <a:latin typeface="Arial"/>
+              </a:defRPr>
+            </a:pPr>
+            <a:r>
+              <a:t>•  Mohamed Hamdy Abdelazez</a:t>
+            </a:r>
+          </a:p>
+          <a:p>
+            <a:pPr>
+              <a:spcAft>
+                <a:spcPts val="800"/>
+              </a:spcAft>
+              <a:defRPr sz="1300" b="1">
+                <a:solidFill>
+                  <a:srgbClr val="F8FAFC"/>
+                </a:solidFill>
+                <a:latin typeface="Arial"/>
+              </a:defRPr>
+            </a:pPr>
+            <a:r>
+              <a:t>•  Asmaa Samy Hagag</a:t>
+            </a:r>
+          </a:p>
+          <a:p>
+            <a:pPr>
+              <a:spcAft>
+                <a:spcPts val="800"/>
+              </a:spcAft>
+              <a:defRPr sz="1300" b="1">
+                <a:solidFill>
+                  <a:srgbClr val="F8FAFC"/>
+                </a:solidFill>
+                <a:latin typeface="Arial"/>
+              </a:defRPr>
+            </a:pPr>
+            <a:r>
+              <a:t>•  Mohamed Abd elhgani el kwatihy</a:t>
+            </a:r>
+          </a:p>
+        </p:txBody>
+      </p:sp>
+    </p:spTree>
+  </p:cSld>
+  <p:clrMapOvr>
+    <a:masterClrMapping/>
+  </p:clrMapOvr>
+</p:sld>
+</file>
+
+<file path=ppt/slides/slide14.xml><?xml version="1.0" encoding="utf-8"?>
+<p:sld xmlns:a="http://schemas.openxmlformats.org/drawingml/2006/main" xmlns:p="http://schemas.openxmlformats.org/presentationml/2006/main" xmlns:r="http://schemas.openxmlformats.org/officeDocument/2006/relationships">
+  <p:cSld>
+    <p:spTree>
+      <p:nvGrpSpPr>
+        <p:cNvPr id="1" name=""/>
+        <p:cNvGrpSpPr/>
+        <p:nvPr/>
+      </p:nvGrpSpPr>
+      <p:grpSpPr/>
+      <p:sp>
+        <p:nvSpPr>
+          <p:cNvPr id="2" name="Rectangle 1"/>
+          <p:cNvSpPr/>
+          <p:nvPr/>
+        </p:nvSpPr>
+        <p:spPr>
+          <a:xfrm>
+            <a:off x="0" y="0"/>
+            <a:ext cx="12191695" cy="6858000"/>
+          </a:xfrm>
+          <a:prstGeom prst="rect">
+            <a:avLst/>
+          </a:prstGeom>
+          <a:solidFill>
+            <a:srgbClr val="0A0E17"/>
+          </a:solidFill>
+          <a:ln>
+            <a:noFill/>
+          </a:ln>
+        </p:spPr>
+        <p:style>
+          <a:lnRef idx="1">
+            <a:schemeClr val="accent1"/>
+          </a:lnRef>
+          <a:fillRef idx="3">
+            <a:schemeClr val="accent1"/>
+          </a:fillRef>
+          <a:effectRef idx="2">
+            <a:schemeClr val="accent1"/>
+          </a:effectRef>
+          <a:fontRef idx="minor">
+            <a:schemeClr val="lt1"/>
+          </a:fontRef>
+        </p:style>
+        <p:txBody>
+          <a:bodyPr rtlCol="0" anchor="ctr"/>
+          <a:lstStyle/>
+          <a:p>
+            <a:pPr algn="ctr"/>
+          </a:p>
+        </p:txBody>
+      </p:sp>
+      <p:sp>
+        <p:nvSpPr>
+          <p:cNvPr id="3" name="TextBox 2"/>
+          <p:cNvSpPr txBox="1"/>
+          <p:nvPr/>
+        </p:nvSpPr>
+        <p:spPr>
+          <a:xfrm>
             <a:off x="1371600" y="1371600"/>
             <a:ext cx="9445752" cy="4114800"/>
           </a:xfrm>
@@ -7114,7 +8306,7 @@
               </a:defRPr>
             </a:pPr>
             <a:r>
-              <a:t>ENGINEERING RIGOR</a:t>
+              <a:t>LIVE SYSTEM INTERFACE</a:t>
             </a:r>
           </a:p>
         </p:txBody>
@@ -7150,7 +8342,7 @@
               </a:defRPr>
             </a:pPr>
             <a:r>
-              <a:t>Technical Breakthroughs: 131k Context &amp; GPU Acceleration</a:t>
+              <a:t>Live Platform Showcase: Knowledge Notebooks &amp; Multi-Source RAG</a:t>
             </a:r>
           </a:p>
         </p:txBody>
@@ -7206,8 +8398,183 @@
         </p:nvSpPr>
         <p:spPr>
           <a:xfrm>
-            <a:off x="731520" y="1645920"/>
-            <a:ext cx="3383280" cy="4572000"/>
+            <a:off x="676656" y="1728216"/>
+            <a:ext cx="6876288" cy="4114800"/>
+          </a:xfrm>
+          <a:prstGeom prst="roundRect">
+            <a:avLst/>
+          </a:prstGeom>
+          <a:solidFill>
+            <a:srgbClr val="111827"/>
+          </a:solidFill>
+          <a:ln w="19050">
+            <a:solidFill>
+              <a:srgbClr val="D4AF37"/>
+            </a:solidFill>
+          </a:ln>
+        </p:spPr>
+        <p:style>
+          <a:lnRef idx="1">
+            <a:schemeClr val="accent1"/>
+          </a:lnRef>
+          <a:fillRef idx="3">
+            <a:schemeClr val="accent1"/>
+          </a:fillRef>
+          <a:effectRef idx="2">
+            <a:schemeClr val="accent1"/>
+          </a:effectRef>
+          <a:fontRef idx="minor">
+            <a:schemeClr val="lt1"/>
+          </a:fontRef>
+        </p:style>
+        <p:txBody>
+          <a:bodyPr rtlCol="0" anchor="ctr"/>
+          <a:lstStyle/>
+          <a:p>
+            <a:pPr algn="ctr"/>
+          </a:p>
+        </p:txBody>
+      </p:sp>
+      <p:pic>
+        <p:nvPicPr>
+          <p:cNvPr id="7" name="Picture 6" descr="tut_ui_notebooks.png"/>
+          <p:cNvPicPr>
+            <a:picLocks noChangeAspect="1"/>
+          </p:cNvPicPr>
+          <p:nvPr/>
+        </p:nvPicPr>
+        <p:blipFill>
+          <a:blip r:embed="rId2"/>
+          <a:stretch>
+            <a:fillRect/>
+          </a:stretch>
+        </p:blipFill>
+        <p:spPr>
+          <a:xfrm>
+            <a:off x="731520" y="1783080"/>
+            <a:ext cx="6766560" cy="4005072"/>
+          </a:xfrm>
+          <a:prstGeom prst="rect">
+            <a:avLst/>
+          </a:prstGeom>
+        </p:spPr>
+      </p:pic>
+      <p:sp>
+        <p:nvSpPr>
+          <p:cNvPr id="8" name="Rounded Rectangle 7"/>
+          <p:cNvSpPr/>
+          <p:nvPr/>
+        </p:nvSpPr>
+        <p:spPr>
+          <a:xfrm>
+            <a:off x="7772400" y="1719072"/>
+            <a:ext cx="3685032" cy="1353312"/>
+          </a:xfrm>
+          <a:prstGeom prst="roundRect">
+            <a:avLst/>
+          </a:prstGeom>
+          <a:solidFill>
+            <a:srgbClr val="111827"/>
+          </a:solidFill>
+          <a:ln w="15240">
+            <a:solidFill>
+              <a:srgbClr val="D4AF37"/>
+            </a:solidFill>
+          </a:ln>
+        </p:spPr>
+        <p:style>
+          <a:lnRef idx="1">
+            <a:schemeClr val="accent1"/>
+          </a:lnRef>
+          <a:fillRef idx="3">
+            <a:schemeClr val="accent1"/>
+          </a:fillRef>
+          <a:effectRef idx="2">
+            <a:schemeClr val="accent1"/>
+          </a:effectRef>
+          <a:fontRef idx="minor">
+            <a:schemeClr val="lt1"/>
+          </a:fontRef>
+        </p:style>
+        <p:txBody>
+          <a:bodyPr rtlCol="0" anchor="ctr" wrap="square" lIns="182880" rIns="182880" tIns="109728" bIns="73152"/>
+          <a:lstStyle/>
+          <a:p>
+            <a:pPr algn="ctr">
+              <a:spcAft>
+                <a:spcPts val="200"/>
+              </a:spcAft>
+              <a:defRPr sz="900" b="1">
+                <a:solidFill>
+                  <a:srgbClr val="D4AF37"/>
+                </a:solidFill>
+                <a:latin typeface="Arial"/>
+              </a:defRPr>
+            </a:pPr>
+            <a:r>
+              <a:t>DATA INGESTION</a:t>
+            </a:r>
+          </a:p>
+          <a:p>
+            <a:pPr>
+              <a:spcAft>
+                <a:spcPts val="400"/>
+              </a:spcAft>
+              <a:defRPr sz="1300" b="1">
+                <a:solidFill>
+                  <a:srgbClr val="F8FAFC"/>
+                </a:solidFill>
+                <a:latin typeface="Arial"/>
+              </a:defRPr>
+            </a:pPr>
+            <a:r>
+              <a:t>Multi-Source Knowledge Ingestion</a:t>
+            </a:r>
+          </a:p>
+          <a:p>
+            <a:pPr>
+              <a:spcAft>
+                <a:spcPts val="200"/>
+              </a:spcAft>
+              <a:defRPr sz="1050">
+                <a:solidFill>
+                  <a:srgbClr val="94A3B8"/>
+                </a:solidFill>
+                <a:latin typeface="Arial"/>
+              </a:defRPr>
+            </a:pPr>
+            <a:r>
+              <a:t>•  Ingests massive governmental PDFs (e.g. WEF Global Risks Report 2024), decrees, and spreadsheets.</a:t>
+            </a:r>
+          </a:p>
+          <a:p>
+            <a:pPr>
+              <a:spcAft>
+                <a:spcPts val="200"/>
+              </a:spcAft>
+              <a:defRPr sz="1050">
+                <a:solidFill>
+                  <a:srgbClr val="94A3B8"/>
+                </a:solidFill>
+                <a:latin typeface="Arial"/>
+              </a:defRPr>
+            </a:pPr>
+            <a:r>
+              <a:t>•  Full-text search &amp; vector embeddings extracted and stored 100% locally.</a:t>
+            </a:r>
+          </a:p>
+        </p:txBody>
+      </p:sp>
+      <p:sp>
+        <p:nvSpPr>
+          <p:cNvPr id="9" name="Rounded Rectangle 8"/>
+          <p:cNvSpPr/>
+          <p:nvPr/>
+        </p:nvSpPr>
+        <p:spPr>
+          <a:xfrm>
+            <a:off x="7772400" y="3218688"/>
+            <a:ext cx="3685032" cy="1353312"/>
           </a:xfrm>
           <a:prstGeom prst="roundRect">
             <a:avLst/>
@@ -7236,30 +8603,30 @@
           </a:fontRef>
         </p:style>
         <p:txBody>
-          <a:bodyPr rtlCol="0" anchor="ctr" wrap="square" lIns="228600" rIns="228600" tIns="228600" bIns="182880"/>
+          <a:bodyPr rtlCol="0" anchor="ctr" wrap="square" lIns="182880" rIns="182880" tIns="109728" bIns="73152"/>
           <a:lstStyle/>
           <a:p>
             <a:pPr algn="ctr">
               <a:spcAft>
+                <a:spcPts val="200"/>
+              </a:spcAft>
+              <a:defRPr sz="900" b="1">
+                <a:solidFill>
+                  <a:srgbClr val="38BDF8"/>
+                </a:solidFill>
+                <a:latin typeface="Arial"/>
+              </a:defRPr>
+            </a:pPr>
+            <a:r>
+              <a:t>SECURITY &amp; ISOLATION</a:t>
+            </a:r>
+          </a:p>
+          <a:p>
+            <a:pPr>
+              <a:spcAft>
                 <a:spcPts val="400"/>
               </a:spcAft>
-              <a:defRPr sz="1000" b="1">
-                <a:solidFill>
-                  <a:srgbClr val="38BDF8"/>
-                </a:solidFill>
-                <a:latin typeface="Arial"/>
-              </a:defRPr>
-            </a:pPr>
-            <a:r>
-              <a:t>MODEL CAPACITY</a:t>
-            </a:r>
-          </a:p>
-          <a:p>
-            <a:pPr>
-              <a:spcAft>
-                <a:spcPts val="1000"/>
-              </a:spcAft>
-              <a:defRPr sz="1600" b="1">
+              <a:defRPr sz="1300" b="1">
                 <a:solidFill>
                   <a:srgbClr val="F8FAFC"/>
                 </a:solidFill>
@@ -7267,15 +8634,15 @@
               </a:defRPr>
             </a:pPr>
             <a:r>
-              <a:t>131k Context Window</a:t>
-            </a:r>
-          </a:p>
-          <a:p>
-            <a:pPr>
-              <a:spcAft>
-                <a:spcPts val="600"/>
-              </a:spcAft>
-              <a:defRPr sz="1200">
+              <a:t>Departmental Notebook Sandboxing</a:t>
+            </a:r>
+          </a:p>
+          <a:p>
+            <a:pPr>
+              <a:spcAft>
+                <a:spcPts val="200"/>
+              </a:spcAft>
+              <a:defRPr sz="1050">
                 <a:solidFill>
                   <a:srgbClr val="94A3B8"/>
                 </a:solidFill>
@@ -7283,15 +8650,15 @@
               </a:defRPr>
             </a:pPr>
             <a:r>
-              <a:t>•  PostgreSQL database tables unlocked to 131,072 context tokens.</a:t>
-            </a:r>
-          </a:p>
-          <a:p>
-            <a:pPr>
-              <a:spcAft>
-                <a:spcPts val="600"/>
-              </a:spcAft>
-              <a:defRPr sz="1200">
+              <a:t>•  Isolated sovereign workspaces ('dsc', 'klh', 'arfa', 'eg') protect departmental boundaries.</a:t>
+            </a:r>
+          </a:p>
+          <a:p>
+            <a:pPr>
+              <a:spcAft>
+                <a:spcPts val="200"/>
+              </a:spcAft>
+              <a:defRPr sz="1050">
                 <a:solidFill>
                   <a:srgbClr val="94A3B8"/>
                 </a:solidFill>
@@ -7299,191 +8666,21 @@
               </a:defRPr>
             </a:pPr>
             <a:r>
-              <a:t>•  16,384 maximum output tokens for exhaustive document generation.</a:t>
-            </a:r>
-          </a:p>
-          <a:p>
-            <a:pPr>
-              <a:spcAft>
-                <a:spcPts val="600"/>
-              </a:spcAft>
-              <a:defRPr sz="1200">
-                <a:solidFill>
-                  <a:srgbClr val="94A3B8"/>
-                </a:solidFill>
-                <a:latin typeface="Arial"/>
-              </a:defRPr>
-            </a:pPr>
-            <a:r>
-              <a:t>•  Eliminates memory truncation: Ingest entire decree books without losing context.</a:t>
-            </a:r>
-          </a:p>
-          <a:p>
-            <a:pPr>
-              <a:spcAft>
-                <a:spcPts val="600"/>
-              </a:spcAft>
-              <a:defRPr sz="1200">
-                <a:solidFill>
-                  <a:srgbClr val="94A3B8"/>
-                </a:solidFill>
-                <a:latin typeface="Arial"/>
-              </a:defRPr>
-            </a:pPr>
-            <a:r>
-              <a:t>•  Reasoning mode: 'pro' with 8,192 dedicated thinking budget.</a:t>
-            </a:r>
-          </a:p>
-        </p:txBody>
-      </p:sp>
-      <p:sp>
-        <p:nvSpPr>
-          <p:cNvPr id="7" name="Rounded Rectangle 6"/>
+              <a:t>•  Prevents data cross-contamination with secure account-level isolation.</a:t>
+            </a:r>
+          </a:p>
+        </p:txBody>
+      </p:sp>
+      <p:sp>
+        <p:nvSpPr>
+          <p:cNvPr id="10" name="Rounded Rectangle 9"/>
           <p:cNvSpPr/>
           <p:nvPr/>
         </p:nvSpPr>
         <p:spPr>
           <a:xfrm>
-            <a:off x="4389120" y="1645920"/>
-            <a:ext cx="3383280" cy="4572000"/>
-          </a:xfrm>
-          <a:prstGeom prst="roundRect">
-            <a:avLst/>
-          </a:prstGeom>
-          <a:solidFill>
-            <a:srgbClr val="111827"/>
-          </a:solidFill>
-          <a:ln w="15240">
-            <a:solidFill>
-              <a:srgbClr val="D4AF37"/>
-            </a:solidFill>
-          </a:ln>
-        </p:spPr>
-        <p:style>
-          <a:lnRef idx="1">
-            <a:schemeClr val="accent1"/>
-          </a:lnRef>
-          <a:fillRef idx="3">
-            <a:schemeClr val="accent1"/>
-          </a:fillRef>
-          <a:effectRef idx="2">
-            <a:schemeClr val="accent1"/>
-          </a:effectRef>
-          <a:fontRef idx="minor">
-            <a:schemeClr val="lt1"/>
-          </a:fontRef>
-        </p:style>
-        <p:txBody>
-          <a:bodyPr rtlCol="0" anchor="ctr" wrap="square" lIns="228600" rIns="228600" tIns="228600" bIns="182880"/>
-          <a:lstStyle/>
-          <a:p>
-            <a:pPr algn="ctr">
-              <a:spcAft>
-                <a:spcPts val="400"/>
-              </a:spcAft>
-              <a:defRPr sz="1000" b="1">
-                <a:solidFill>
-                  <a:srgbClr val="D4AF37"/>
-                </a:solidFill>
-                <a:latin typeface="Arial"/>
-              </a:defRPr>
-            </a:pPr>
-            <a:r>
-              <a:t>VELOCITY</a:t>
-            </a:r>
-          </a:p>
-          <a:p>
-            <a:pPr>
-              <a:spcAft>
-                <a:spcPts val="1000"/>
-              </a:spcAft>
-              <a:defRPr sz="1600" b="1">
-                <a:solidFill>
-                  <a:srgbClr val="F8FAFC"/>
-                </a:solidFill>
-                <a:latin typeface="Arial"/>
-              </a:defRPr>
-            </a:pPr>
-            <a:r>
-              <a:t>NVIDIA RTX 4050 GPU VRAM</a:t>
-            </a:r>
-          </a:p>
-          <a:p>
-            <a:pPr>
-              <a:spcAft>
-                <a:spcPts val="600"/>
-              </a:spcAft>
-              <a:defRPr sz="1200">
-                <a:solidFill>
-                  <a:srgbClr val="94A3B8"/>
-                </a:solidFill>
-                <a:latin typeface="Arial"/>
-              </a:defRPr>
-            </a:pPr>
-            <a:r>
-              <a:t>•  Pinned local gemma4:e4b weights in dedicated 5.1 GB GPU VRAM.</a:t>
-            </a:r>
-          </a:p>
-          <a:p>
-            <a:pPr>
-              <a:spcAft>
-                <a:spcPts val="600"/>
-              </a:spcAft>
-              <a:defRPr sz="1200">
-                <a:solidFill>
-                  <a:srgbClr val="94A3B8"/>
-                </a:solidFill>
-                <a:latin typeface="Arial"/>
-              </a:defRPr>
-            </a:pPr>
-            <a:r>
-              <a:t>•  Configured keep_alive: '-1' to completely eliminate cold-start unloading.</a:t>
-            </a:r>
-          </a:p>
-          <a:p>
-            <a:pPr>
-              <a:spcAft>
-                <a:spcPts val="600"/>
-              </a:spcAft>
-              <a:defRPr sz="1200">
-                <a:solidFill>
-                  <a:srgbClr val="94A3B8"/>
-                </a:solidFill>
-                <a:latin typeface="Arial"/>
-              </a:defRPr>
-            </a:pPr>
-            <a:r>
-              <a:t>•  Instant response velocity: First token streamed in milliseconds.</a:t>
-            </a:r>
-          </a:p>
-          <a:p>
-            <a:pPr>
-              <a:spcAft>
-                <a:spcPts val="600"/>
-              </a:spcAft>
-              <a:defRPr sz="1200">
-                <a:solidFill>
-                  <a:srgbClr val="94A3B8"/>
-                </a:solidFill>
-                <a:latin typeface="Arial"/>
-              </a:defRPr>
-            </a:pPr>
-            <a:r>
-              <a:t>•  Optimized for smooth pair programming and multi-turn conversational agents.</a:t>
-            </a:r>
-          </a:p>
-        </p:txBody>
-      </p:sp>
-      <p:sp>
-        <p:nvSpPr>
-          <p:cNvPr id="8" name="Rounded Rectangle 7"/>
-          <p:cNvSpPr/>
-          <p:nvPr/>
-        </p:nvSpPr>
-        <p:spPr>
-          <a:xfrm>
-            <a:off x="8046720" y="1645920"/>
-            <a:ext cx="3383280" cy="4572000"/>
+            <a:off x="7772400" y="4718304"/>
+            <a:ext cx="3685032" cy="1353312"/>
           </a:xfrm>
           <a:prstGeom prst="roundRect">
             <a:avLst/>
@@ -7512,30 +8709,30 @@
           </a:fontRef>
         </p:style>
         <p:txBody>
-          <a:bodyPr rtlCol="0" anchor="ctr" wrap="square" lIns="228600" rIns="228600" tIns="228600" bIns="182880"/>
+          <a:bodyPr rtlCol="0" anchor="ctr" wrap="square" lIns="182880" rIns="182880" tIns="109728" bIns="73152"/>
           <a:lstStyle/>
           <a:p>
             <a:pPr algn="ctr">
               <a:spcAft>
+                <a:spcPts val="200"/>
+              </a:spcAft>
+              <a:defRPr sz="900" b="1">
+                <a:solidFill>
+                  <a:srgbClr val="34D399"/>
+                </a:solidFill>
+                <a:latin typeface="Arial"/>
+              </a:defRPr>
+            </a:pPr>
+            <a:r>
+              <a:t>MCIT PROVENANCE</a:t>
+            </a:r>
+          </a:p>
+          <a:p>
+            <a:pPr>
+              <a:spcAft>
                 <a:spcPts val="400"/>
               </a:spcAft>
-              <a:defRPr sz="1000" b="1">
-                <a:solidFill>
-                  <a:srgbClr val="34D399"/>
-                </a:solidFill>
-                <a:latin typeface="Arial"/>
-              </a:defRPr>
-            </a:pPr>
-            <a:r>
-              <a:t>RESILIENCE</a:t>
-            </a:r>
-          </a:p>
-          <a:p>
-            <a:pPr>
-              <a:spcAft>
-                <a:spcPts val="1000"/>
-              </a:spcAft>
-              <a:defRPr sz="1600" b="1">
+              <a:defRPr sz="1300" b="1">
                 <a:solidFill>
                   <a:srgbClr val="F8FAFC"/>
                 </a:solidFill>
@@ -7543,15 +8740,15 @@
               </a:defRPr>
             </a:pPr>
             <a:r>
-              <a:t>Self-Healing Docker Stack</a:t>
-            </a:r>
-          </a:p>
-          <a:p>
-            <a:pPr>
-              <a:spcAft>
-                <a:spcPts val="600"/>
-              </a:spcAft>
-              <a:defRPr sz="1200">
+              <a:t>Sovereign National Attribution</a:t>
+            </a:r>
+          </a:p>
+          <a:p>
+            <a:pPr>
+              <a:spcAft>
+                <a:spcPts val="200"/>
+              </a:spcAft>
+              <a:defRPr sz="1050">
                 <a:solidFill>
                   <a:srgbClr val="94A3B8"/>
                 </a:solidFill>
@@ -7559,15 +8756,15 @@
               </a:defRPr>
             </a:pPr>
             <a:r>
-              <a:t>•  11 isolated Docker services: Agent, Platform, ONLYOFFICE, SurrealDB, Postgres, Redis, Kokoro.</a:t>
-            </a:r>
-          </a:p>
-          <a:p>
-            <a:pPr>
-              <a:spcAft>
-                <a:spcPts val="600"/>
-              </a:spcAft>
-              <a:defRPr sz="1200">
+              <a:t>•  Custom-built for the Ministry of Communications &amp; Information Technology.</a:t>
+            </a:r>
+          </a:p>
+          <a:p>
+            <a:pPr>
+              <a:spcAft>
+                <a:spcPts val="200"/>
+              </a:spcAft>
+              <a:defRPr sz="1050">
                 <a:solidFill>
                   <a:srgbClr val="94A3B8"/>
                 </a:solidFill>
@@ -7575,39 +8772,7 @@
               </a:defRPr>
             </a:pPr>
             <a:r>
-              <a:t>•  Built-in runtime self-patching in startServer.js guarantees TRPC stability on container boot.</a:t>
-            </a:r>
-          </a:p>
-          <a:p>
-            <a:pPr>
-              <a:spcAft>
-                <a:spcPts val="600"/>
-              </a:spcAft>
-              <a:defRPr sz="1200">
-                <a:solidFill>
-                  <a:srgbClr val="94A3B8"/>
-                </a:solidFill>
-                <a:latin typeface="Arial"/>
-              </a:defRPr>
-            </a:pPr>
-            <a:r>
-              <a:t>•  Turnkey 1-click bootstrap scripts (.ps1 and .sh) launch the full ecosystem in under 15 seconds.</a:t>
-            </a:r>
-          </a:p>
-          <a:p>
-            <a:pPr>
-              <a:spcAft>
-                <a:spcPts val="600"/>
-              </a:spcAft>
-              <a:defRPr sz="1200">
-                <a:solidFill>
-                  <a:srgbClr val="94A3B8"/>
-                </a:solidFill>
-                <a:latin typeface="Arial"/>
-              </a:defRPr>
-            </a:pPr>
-            <a:r>
-              <a:t>•  All source code versioned on GitHub: AhmdArFa/TuT-AI.</a:t>
+              <a:t>•  Verified interface attribution: 'Developed by Eng Ahmed Arfa for MCIT'.</a:t>
             </a:r>
           </a:p>
         </p:txBody>
@@ -7704,7 +8869,7 @@
               </a:defRPr>
             </a:pPr>
             <a:r>
-              <a:t>ENGINEERING MILESTONES</a:t>
+              <a:t>CONVERSATIONAL INTELLIGENCE</a:t>
             </a:r>
           </a:p>
         </p:txBody>
@@ -7740,7 +8905,7 @@
               </a:defRPr>
             </a:pPr>
             <a:r>
-              <a:t>The Development Journey: 4 Evolutionary Phases</a:t>
+              <a:t>Live Agent Showcase: In-Chat Deck Generation &amp; 3D Avatar</a:t>
             </a:r>
           </a:p>
         </p:txBody>
@@ -7796,8 +8961,77 @@
         </p:nvSpPr>
         <p:spPr>
           <a:xfrm>
-            <a:off x="731520" y="1645920"/>
-            <a:ext cx="5212080" cy="2194560"/>
+            <a:off x="676656" y="1728216"/>
+            <a:ext cx="6876288" cy="4114800"/>
+          </a:xfrm>
+          <a:prstGeom prst="roundRect">
+            <a:avLst/>
+          </a:prstGeom>
+          <a:solidFill>
+            <a:srgbClr val="111827"/>
+          </a:solidFill>
+          <a:ln w="19050">
+            <a:solidFill>
+              <a:srgbClr val="38BDF8"/>
+            </a:solidFill>
+          </a:ln>
+        </p:spPr>
+        <p:style>
+          <a:lnRef idx="1">
+            <a:schemeClr val="accent1"/>
+          </a:lnRef>
+          <a:fillRef idx="3">
+            <a:schemeClr val="accent1"/>
+          </a:fillRef>
+          <a:effectRef idx="2">
+            <a:schemeClr val="accent1"/>
+          </a:effectRef>
+          <a:fontRef idx="minor">
+            <a:schemeClr val="lt1"/>
+          </a:fontRef>
+        </p:style>
+        <p:txBody>
+          <a:bodyPr rtlCol="0" anchor="ctr"/>
+          <a:lstStyle/>
+          <a:p>
+            <a:pPr algn="ctr"/>
+          </a:p>
+        </p:txBody>
+      </p:sp>
+      <p:pic>
+        <p:nvPicPr>
+          <p:cNvPr id="7" name="Picture 6" descr="tut_ui_agent.png"/>
+          <p:cNvPicPr>
+            <a:picLocks noChangeAspect="1"/>
+          </p:cNvPicPr>
+          <p:nvPr/>
+        </p:nvPicPr>
+        <p:blipFill>
+          <a:blip r:embed="rId2"/>
+          <a:stretch>
+            <a:fillRect/>
+          </a:stretch>
+        </p:blipFill>
+        <p:spPr>
+          <a:xfrm>
+            <a:off x="731520" y="1783080"/>
+            <a:ext cx="6766560" cy="4005072"/>
+          </a:xfrm>
+          <a:prstGeom prst="rect">
+            <a:avLst/>
+          </a:prstGeom>
+        </p:spPr>
+      </p:pic>
+      <p:sp>
+        <p:nvSpPr>
+          <p:cNvPr id="8" name="Rounded Rectangle 7"/>
+          <p:cNvSpPr/>
+          <p:nvPr/>
+        </p:nvSpPr>
+        <p:spPr>
+          <a:xfrm>
+            <a:off x="7772400" y="1719072"/>
+            <a:ext cx="3685032" cy="1353312"/>
           </a:xfrm>
           <a:prstGeom prst="roundRect">
             <a:avLst/>
@@ -7826,30 +9060,30 @@
           </a:fontRef>
         </p:style>
         <p:txBody>
-          <a:bodyPr rtlCol="0" anchor="ctr" wrap="square" lIns="228600" rIns="228600" tIns="228600" bIns="182880"/>
+          <a:bodyPr rtlCol="0" anchor="ctr" wrap="square" lIns="182880" rIns="182880" tIns="109728" bIns="73152"/>
           <a:lstStyle/>
           <a:p>
             <a:pPr algn="ctr">
               <a:spcAft>
+                <a:spcPts val="200"/>
+              </a:spcAft>
+              <a:defRPr sz="900" b="1">
+                <a:solidFill>
+                  <a:srgbClr val="D4AF37"/>
+                </a:solidFill>
+                <a:latin typeface="Arial"/>
+              </a:defRPr>
+            </a:pPr>
+            <a:r>
+              <a:t>SOVEREIGN IDENTITY</a:t>
+            </a:r>
+          </a:p>
+          <a:p>
+            <a:pPr>
+              <a:spcAft>
                 <a:spcPts val="400"/>
               </a:spcAft>
-              <a:defRPr sz="1000" b="1">
-                <a:solidFill>
-                  <a:srgbClr val="D4AF37"/>
-                </a:solidFill>
-                <a:latin typeface="Arial"/>
-              </a:defRPr>
-            </a:pPr>
-            <a:r>
-              <a:t>PHASE 1: INCEPTION</a:t>
-            </a:r>
-          </a:p>
-          <a:p>
-            <a:pPr>
-              <a:spcAft>
-                <a:spcPts val="1000"/>
-              </a:spcAft>
-              <a:defRPr sz="1600" b="1">
+              <a:defRPr sz="1300" b="1">
                 <a:solidFill>
                   <a:srgbClr val="F8FAFC"/>
                 </a:solidFill>
@@ -7857,15 +9091,15 @@
               </a:defRPr>
             </a:pPr>
             <a:r>
-              <a:t>Phase 1: Foundation &amp; Sovereign Identity</a:t>
-            </a:r>
-          </a:p>
-          <a:p>
-            <a:pPr>
-              <a:spcAft>
-                <a:spcPts val="600"/>
-              </a:spcAft>
-              <a:defRPr sz="1200">
+              <a:t>3D Holographic Sovereign Avatar</a:t>
+            </a:r>
+          </a:p>
+          <a:p>
+            <a:pPr>
+              <a:spcAft>
+                <a:spcPts val="200"/>
+              </a:spcAft>
+              <a:defRPr sz="1050">
                 <a:solidFill>
                   <a:srgbClr val="94A3B8"/>
                 </a:solidFill>
@@ -7873,15 +9107,15 @@
               </a:defRPr>
             </a:pPr>
             <a:r>
-              <a:t>•  Transitioned away from generic third-party code to 100% Egyptian sovereign platform.</a:t>
-            </a:r>
-          </a:p>
-          <a:p>
-            <a:pPr>
-              <a:spcAft>
-                <a:spcPts val="600"/>
-              </a:spcAft>
-              <a:defRPr sz="1200">
+              <a:t>•  Interactive real-time 3D King Tut avatar blending Egyptian heritage with state-of-the-art AI.</a:t>
+            </a:r>
+          </a:p>
+          <a:p>
+            <a:pPr>
+              <a:spcAft>
+                <a:spcPts val="200"/>
+              </a:spcAft>
+              <a:defRPr sz="1050">
                 <a:solidFill>
                   <a:srgbClr val="94A3B8"/>
                 </a:solidFill>
@@ -7889,21 +9123,21 @@
               </a:defRPr>
             </a:pPr>
             <a:r>
-              <a:t>•  Engineered the TuT AI identity: 10 historical personas &amp; 3D holographic cartouche.</a:t>
-            </a:r>
-          </a:p>
-        </p:txBody>
-      </p:sp>
-      <p:sp>
-        <p:nvSpPr>
-          <p:cNvPr id="7" name="Rounded Rectangle 6"/>
+              <a:t>•  Dynamic state cues respond to thought cycles and generation stages.</a:t>
+            </a:r>
+          </a:p>
+        </p:txBody>
+      </p:sp>
+      <p:sp>
+        <p:nvSpPr>
+          <p:cNvPr id="9" name="Rounded Rectangle 8"/>
           <p:cNvSpPr/>
           <p:nvPr/>
         </p:nvSpPr>
         <p:spPr>
           <a:xfrm>
-            <a:off x="6217920" y="1645920"/>
-            <a:ext cx="5212080" cy="2194560"/>
+            <a:off x="7772400" y="3218688"/>
+            <a:ext cx="3685032" cy="1353312"/>
           </a:xfrm>
           <a:prstGeom prst="roundRect">
             <a:avLst/>
@@ -7932,30 +9166,30 @@
           </a:fontRef>
         </p:style>
         <p:txBody>
-          <a:bodyPr rtlCol="0" anchor="ctr" wrap="square" lIns="228600" rIns="228600" tIns="228600" bIns="182880"/>
+          <a:bodyPr rtlCol="0" anchor="ctr" wrap="square" lIns="182880" rIns="182880" tIns="109728" bIns="73152"/>
           <a:lstStyle/>
           <a:p>
             <a:pPr algn="ctr">
               <a:spcAft>
+                <a:spcPts val="200"/>
+              </a:spcAft>
+              <a:defRPr sz="900" b="1">
+                <a:solidFill>
+                  <a:srgbClr val="38BDF8"/>
+                </a:solidFill>
+                <a:latin typeface="Arial"/>
+              </a:defRPr>
+            </a:pPr>
+            <a:r>
+              <a:t>DECKCRAFT ENGINE</a:t>
+            </a:r>
+          </a:p>
+          <a:p>
+            <a:pPr>
+              <a:spcAft>
                 <a:spcPts val="400"/>
               </a:spcAft>
-              <a:defRPr sz="1000" b="1">
-                <a:solidFill>
-                  <a:srgbClr val="38BDF8"/>
-                </a:solidFill>
-                <a:latin typeface="Arial"/>
-              </a:defRPr>
-            </a:pPr>
-            <a:r>
-              <a:t>PHASE 2: ARCHITECTURE</a:t>
-            </a:r>
-          </a:p>
-          <a:p>
-            <a:pPr>
-              <a:spcAft>
-                <a:spcPts val="1000"/>
-              </a:spcAft>
-              <a:defRPr sz="1600" b="1">
+              <a:defRPr sz="1300" b="1">
                 <a:solidFill>
                   <a:srgbClr val="F8FAFC"/>
                 </a:solidFill>
@@ -7963,15 +9197,15 @@
               </a:defRPr>
             </a:pPr>
             <a:r>
-              <a:t>Phase 2: Core Engines &amp; Resilient Fixes</a:t>
-            </a:r>
-          </a:p>
-          <a:p>
-            <a:pPr>
-              <a:spcAft>
-                <a:spcPts val="600"/>
-              </a:spcAft>
-              <a:defRPr sz="1200">
+              <a:t>In-Chat Autonomous Presentation Engine</a:t>
+            </a:r>
+          </a:p>
+          <a:p>
+            <a:pPr>
+              <a:spcAft>
+                <a:spcPts val="200"/>
+              </a:spcAft>
+              <a:defRPr sz="1050">
                 <a:solidFill>
                   <a:srgbClr val="94A3B8"/>
                 </a:solidFill>
@@ -7979,15 +9213,15 @@
               </a:defRPr>
             </a:pPr>
             <a:r>
-              <a:t>•  Engineered the 3 pillars: Deep Summarization, DeckCraft (.pptx), and VectorCraft (infographics).</a:t>
-            </a:r>
-          </a:p>
-          <a:p>
-            <a:pPr>
-              <a:spcAft>
-                <a:spcPts val="600"/>
-              </a:spcAft>
-              <a:defRPr sz="1200">
+              <a:t>•  Live conversational workflow: User asks in Arabic for presentations on complex national topics.</a:t>
+            </a:r>
+          </a:p>
+          <a:p>
+            <a:pPr>
+              <a:spcAft>
+                <a:spcPts val="200"/>
+              </a:spcAft>
+              <a:defRPr sz="1050">
                 <a:solidFill>
                   <a:srgbClr val="94A3B8"/>
                 </a:solidFill>
@@ -7995,21 +9229,21 @@
               </a:defRPr>
             </a:pPr>
             <a:r>
-              <a:t>•  Resolved TRPC runtime crashes via intelligent local Ollama fallback proxy.</a:t>
-            </a:r>
-          </a:p>
-        </p:txBody>
-      </p:sp>
-      <p:sp>
-        <p:nvSpPr>
-          <p:cNvPr id="8" name="Rounded Rectangle 7"/>
+              <a:t>•  Generates genuine, fully editable PowerPoint decks (.pptx) right inside chat.</a:t>
+            </a:r>
+          </a:p>
+        </p:txBody>
+      </p:sp>
+      <p:sp>
+        <p:nvSpPr>
+          <p:cNvPr id="10" name="Rounded Rectangle 9"/>
           <p:cNvSpPr/>
           <p:nvPr/>
         </p:nvSpPr>
         <p:spPr>
           <a:xfrm>
-            <a:off x="731520" y="4023360"/>
-            <a:ext cx="5212080" cy="2194560"/>
+            <a:off x="7772400" y="4718304"/>
+            <a:ext cx="3685032" cy="1353312"/>
           </a:xfrm>
           <a:prstGeom prst="roundRect">
             <a:avLst/>
@@ -8038,30 +9272,30 @@
           </a:fontRef>
         </p:style>
         <p:txBody>
-          <a:bodyPr rtlCol="0" anchor="ctr" wrap="square" lIns="228600" rIns="228600" tIns="228600" bIns="182880"/>
+          <a:bodyPr rtlCol="0" anchor="ctr" wrap="square" lIns="182880" rIns="182880" tIns="109728" bIns="73152"/>
           <a:lstStyle/>
           <a:p>
             <a:pPr algn="ctr">
               <a:spcAft>
+                <a:spcPts val="200"/>
+              </a:spcAft>
+              <a:defRPr sz="900" b="1">
+                <a:solidFill>
+                  <a:srgbClr val="34D399"/>
+                </a:solidFill>
+                <a:latin typeface="Arial"/>
+              </a:defRPr>
+            </a:pPr>
+            <a:r>
+              <a:t>GPU ACCELERATION</a:t>
+            </a:r>
+          </a:p>
+          <a:p>
+            <a:pPr>
+              <a:spcAft>
                 <a:spcPts val="400"/>
               </a:spcAft>
-              <a:defRPr sz="1000" b="1">
-                <a:solidFill>
-                  <a:srgbClr val="34D399"/>
-                </a:solidFill>
-                <a:latin typeface="Arial"/>
-              </a:defRPr>
-            </a:pPr>
-            <a:r>
-              <a:t>PHASE 3: INTELLIGENCE</a:t>
-            </a:r>
-          </a:p>
-          <a:p>
-            <a:pPr>
-              <a:spcAft>
-                <a:spcPts val="1000"/>
-              </a:spcAft>
-              <a:defRPr sz="1600" b="1">
+              <a:defRPr sz="1300" b="1">
                 <a:solidFill>
                   <a:srgbClr val="F8FAFC"/>
                 </a:solidFill>
@@ -8069,15 +9303,15 @@
               </a:defRPr>
             </a:pPr>
             <a:r>
-              <a:t>Phase 3: Model Intelligence &amp; GPU Velocity</a:t>
-            </a:r>
-          </a:p>
-          <a:p>
-            <a:pPr>
-              <a:spcAft>
-                <a:spcPts val="600"/>
-              </a:spcAft>
-              <a:defRPr sz="1200">
+              <a:t>Pinned Local Gemma 4 Engine</a:t>
+            </a:r>
+          </a:p>
+          <a:p>
+            <a:pPr>
+              <a:spcAft>
+                <a:spcPts val="200"/>
+              </a:spcAft>
+              <a:defRPr sz="1050">
                 <a:solidFill>
                   <a:srgbClr val="94A3B8"/>
                 </a:solidFill>
@@ -8085,15 +9319,15 @@
               </a:defRPr>
             </a:pPr>
             <a:r>
-              <a:t>•  Unlocked database to 131,072 context tokens, 16,384 output tokens, and 'pro' reasoning.</a:t>
-            </a:r>
-          </a:p>
-          <a:p>
-            <a:pPr>
-              <a:spcAft>
-                <a:spcPts val="600"/>
-              </a:spcAft>
-              <a:defRPr sz="1200">
+              <a:t>•  Powered by Gemma 4 e4b pinned directly in NVIDIA RTX GPU VRAM.</a:t>
+            </a:r>
+          </a:p>
+          <a:p>
+            <a:pPr>
+              <a:spcAft>
+                <a:spcPts val="200"/>
+              </a:spcAft>
+              <a:defRPr sz="1050">
                 <a:solidFill>
                   <a:srgbClr val="94A3B8"/>
                 </a:solidFill>
@@ -8101,113 +9335,7 @@
               </a:defRPr>
             </a:pPr>
             <a:r>
-              <a:t>•  Pinned gemma4:e4b into NVIDIA RTX 4050 GPU VRAM (keep_alive: '-1') for instant streaming.</a:t>
-            </a:r>
-          </a:p>
-        </p:txBody>
-      </p:sp>
-      <p:sp>
-        <p:nvSpPr>
-          <p:cNvPr id="9" name="Rounded Rectangle 8"/>
-          <p:cNvSpPr/>
-          <p:nvPr/>
-        </p:nvSpPr>
-        <p:spPr>
-          <a:xfrm>
-            <a:off x="6217920" y="4023360"/>
-            <a:ext cx="5212080" cy="2194560"/>
-          </a:xfrm>
-          <a:prstGeom prst="roundRect">
-            <a:avLst/>
-          </a:prstGeom>
-          <a:solidFill>
-            <a:srgbClr val="111827"/>
-          </a:solidFill>
-          <a:ln w="15240">
-            <a:solidFill>
-              <a:srgbClr val="F59E0B"/>
-            </a:solidFill>
-          </a:ln>
-        </p:spPr>
-        <p:style>
-          <a:lnRef idx="1">
-            <a:schemeClr val="accent1"/>
-          </a:lnRef>
-          <a:fillRef idx="3">
-            <a:schemeClr val="accent1"/>
-          </a:fillRef>
-          <a:effectRef idx="2">
-            <a:schemeClr val="accent1"/>
-          </a:effectRef>
-          <a:fontRef idx="minor">
-            <a:schemeClr val="lt1"/>
-          </a:fontRef>
-        </p:style>
-        <p:txBody>
-          <a:bodyPr rtlCol="0" anchor="ctr" wrap="square" lIns="228600" rIns="228600" tIns="228600" bIns="182880"/>
-          <a:lstStyle/>
-          <a:p>
-            <a:pPr algn="ctr">
-              <a:spcAft>
-                <a:spcPts val="400"/>
-              </a:spcAft>
-              <a:defRPr sz="1000" b="1">
-                <a:solidFill>
-                  <a:srgbClr val="F59E0B"/>
-                </a:solidFill>
-                <a:latin typeface="Arial"/>
-              </a:defRPr>
-            </a:pPr>
-            <a:r>
-              <a:t>PHASE 4: PRODUCTION</a:t>
-            </a:r>
-          </a:p>
-          <a:p>
-            <a:pPr>
-              <a:spcAft>
-                <a:spcPts val="1000"/>
-              </a:spcAft>
-              <a:defRPr sz="1600" b="1">
-                <a:solidFill>
-                  <a:srgbClr val="F8FAFC"/>
-                </a:solidFill>
-                <a:latin typeface="Arial"/>
-              </a:defRPr>
-            </a:pPr>
-            <a:r>
-              <a:t>Phase 4: Turnkey Production &amp; GitHub Release</a:t>
-            </a:r>
-          </a:p>
-          <a:p>
-            <a:pPr>
-              <a:spcAft>
-                <a:spcPts val="600"/>
-              </a:spcAft>
-              <a:defRPr sz="1200">
-                <a:solidFill>
-                  <a:srgbClr val="94A3B8"/>
-                </a:solidFill>
-                <a:latin typeface="Arial"/>
-              </a:defRPr>
-            </a:pPr>
-            <a:r>
-              <a:t>•  Built self-healing Docker architecture and turnkey 1-click setup scripts (.ps1 and .sh).</a:t>
-            </a:r>
-          </a:p>
-          <a:p>
-            <a:pPr>
-              <a:spcAft>
-                <a:spcPts val="600"/>
-              </a:spcAft>
-              <a:defRPr sz="1200">
-                <a:solidFill>
-                  <a:srgbClr val="94A3B8"/>
-                </a:solidFill>
-                <a:latin typeface="Arial"/>
-              </a:defRPr>
-            </a:pPr>
-            <a:r>
-              <a:t>•  Integrated ONLYOFFICE document server and published full production repo to GitHub.</a:t>
+              <a:t>•  Instant token streaming with zero latency and 100% offline data privacy.</a:t>
             </a:r>
           </a:p>
         </p:txBody>
@@ -8304,7 +9432,7 @@
               </a:defRPr>
             </a:pPr>
             <a:r>
-              <a:t>INSTITUTIONAL VALUE</a:t>
+              <a:t>ENGINEERING RIGOR</a:t>
             </a:r>
           </a:p>
         </p:txBody>
@@ -8340,7 +9468,7 @@
               </a:defRPr>
             </a:pPr>
             <a:r>
-              <a:t>Strategic &amp; Economic Impact for MCIT &amp; Government</a:t>
+              <a:t>Technical Breakthroughs: 131k Context &amp; GPU Acceleration</a:t>
             </a:r>
           </a:p>
         </p:txBody>
@@ -8397,6 +9525,282 @@
         <p:spPr>
           <a:xfrm>
             <a:off x="731520" y="1645920"/>
+            <a:ext cx="3383280" cy="4572000"/>
+          </a:xfrm>
+          <a:prstGeom prst="roundRect">
+            <a:avLst/>
+          </a:prstGeom>
+          <a:solidFill>
+            <a:srgbClr val="111827"/>
+          </a:solidFill>
+          <a:ln w="15240">
+            <a:solidFill>
+              <a:srgbClr val="38BDF8"/>
+            </a:solidFill>
+          </a:ln>
+        </p:spPr>
+        <p:style>
+          <a:lnRef idx="1">
+            <a:schemeClr val="accent1"/>
+          </a:lnRef>
+          <a:fillRef idx="3">
+            <a:schemeClr val="accent1"/>
+          </a:fillRef>
+          <a:effectRef idx="2">
+            <a:schemeClr val="accent1"/>
+          </a:effectRef>
+          <a:fontRef idx="minor">
+            <a:schemeClr val="lt1"/>
+          </a:fontRef>
+        </p:style>
+        <p:txBody>
+          <a:bodyPr rtlCol="0" anchor="ctr" wrap="square" lIns="228600" rIns="228600" tIns="228600" bIns="182880"/>
+          <a:lstStyle/>
+          <a:p>
+            <a:pPr algn="ctr">
+              <a:spcAft>
+                <a:spcPts val="400"/>
+              </a:spcAft>
+              <a:defRPr sz="1000" b="1">
+                <a:solidFill>
+                  <a:srgbClr val="38BDF8"/>
+                </a:solidFill>
+                <a:latin typeface="Arial"/>
+              </a:defRPr>
+            </a:pPr>
+            <a:r>
+              <a:t>MODEL CAPACITY</a:t>
+            </a:r>
+          </a:p>
+          <a:p>
+            <a:pPr>
+              <a:spcAft>
+                <a:spcPts val="1000"/>
+              </a:spcAft>
+              <a:defRPr sz="1600" b="1">
+                <a:solidFill>
+                  <a:srgbClr val="F8FAFC"/>
+                </a:solidFill>
+                <a:latin typeface="Arial"/>
+              </a:defRPr>
+            </a:pPr>
+            <a:r>
+              <a:t>131k Context Window</a:t>
+            </a:r>
+          </a:p>
+          <a:p>
+            <a:pPr>
+              <a:spcAft>
+                <a:spcPts val="600"/>
+              </a:spcAft>
+              <a:defRPr sz="1200">
+                <a:solidFill>
+                  <a:srgbClr val="94A3B8"/>
+                </a:solidFill>
+                <a:latin typeface="Arial"/>
+              </a:defRPr>
+            </a:pPr>
+            <a:r>
+              <a:t>•  PostgreSQL database tables unlocked to 131,072 context tokens.</a:t>
+            </a:r>
+          </a:p>
+          <a:p>
+            <a:pPr>
+              <a:spcAft>
+                <a:spcPts val="600"/>
+              </a:spcAft>
+              <a:defRPr sz="1200">
+                <a:solidFill>
+                  <a:srgbClr val="94A3B8"/>
+                </a:solidFill>
+                <a:latin typeface="Arial"/>
+              </a:defRPr>
+            </a:pPr>
+            <a:r>
+              <a:t>•  16,384 maximum output tokens for exhaustive document generation.</a:t>
+            </a:r>
+          </a:p>
+          <a:p>
+            <a:pPr>
+              <a:spcAft>
+                <a:spcPts val="600"/>
+              </a:spcAft>
+              <a:defRPr sz="1200">
+                <a:solidFill>
+                  <a:srgbClr val="94A3B8"/>
+                </a:solidFill>
+                <a:latin typeface="Arial"/>
+              </a:defRPr>
+            </a:pPr>
+            <a:r>
+              <a:t>•  Eliminates memory truncation: Ingest entire decree books without losing context.</a:t>
+            </a:r>
+          </a:p>
+          <a:p>
+            <a:pPr>
+              <a:spcAft>
+                <a:spcPts val="600"/>
+              </a:spcAft>
+              <a:defRPr sz="1200">
+                <a:solidFill>
+                  <a:srgbClr val="94A3B8"/>
+                </a:solidFill>
+                <a:latin typeface="Arial"/>
+              </a:defRPr>
+            </a:pPr>
+            <a:r>
+              <a:t>•  Reasoning mode: 'pro' with 8,192 dedicated thinking budget.</a:t>
+            </a:r>
+          </a:p>
+        </p:txBody>
+      </p:sp>
+      <p:sp>
+        <p:nvSpPr>
+          <p:cNvPr id="7" name="Rounded Rectangle 6"/>
+          <p:cNvSpPr/>
+          <p:nvPr/>
+        </p:nvSpPr>
+        <p:spPr>
+          <a:xfrm>
+            <a:off x="4389120" y="1645920"/>
+            <a:ext cx="3383280" cy="4572000"/>
+          </a:xfrm>
+          <a:prstGeom prst="roundRect">
+            <a:avLst/>
+          </a:prstGeom>
+          <a:solidFill>
+            <a:srgbClr val="111827"/>
+          </a:solidFill>
+          <a:ln w="15240">
+            <a:solidFill>
+              <a:srgbClr val="D4AF37"/>
+            </a:solidFill>
+          </a:ln>
+        </p:spPr>
+        <p:style>
+          <a:lnRef idx="1">
+            <a:schemeClr val="accent1"/>
+          </a:lnRef>
+          <a:fillRef idx="3">
+            <a:schemeClr val="accent1"/>
+          </a:fillRef>
+          <a:effectRef idx="2">
+            <a:schemeClr val="accent1"/>
+          </a:effectRef>
+          <a:fontRef idx="minor">
+            <a:schemeClr val="lt1"/>
+          </a:fontRef>
+        </p:style>
+        <p:txBody>
+          <a:bodyPr rtlCol="0" anchor="ctr" wrap="square" lIns="228600" rIns="228600" tIns="228600" bIns="182880"/>
+          <a:lstStyle/>
+          <a:p>
+            <a:pPr algn="ctr">
+              <a:spcAft>
+                <a:spcPts val="400"/>
+              </a:spcAft>
+              <a:defRPr sz="1000" b="1">
+                <a:solidFill>
+                  <a:srgbClr val="D4AF37"/>
+                </a:solidFill>
+                <a:latin typeface="Arial"/>
+              </a:defRPr>
+            </a:pPr>
+            <a:r>
+              <a:t>VELOCITY</a:t>
+            </a:r>
+          </a:p>
+          <a:p>
+            <a:pPr>
+              <a:spcAft>
+                <a:spcPts val="1000"/>
+              </a:spcAft>
+              <a:defRPr sz="1600" b="1">
+                <a:solidFill>
+                  <a:srgbClr val="F8FAFC"/>
+                </a:solidFill>
+                <a:latin typeface="Arial"/>
+              </a:defRPr>
+            </a:pPr>
+            <a:r>
+              <a:t>NVIDIA RTX 4050 GPU VRAM</a:t>
+            </a:r>
+          </a:p>
+          <a:p>
+            <a:pPr>
+              <a:spcAft>
+                <a:spcPts val="600"/>
+              </a:spcAft>
+              <a:defRPr sz="1200">
+                <a:solidFill>
+                  <a:srgbClr val="94A3B8"/>
+                </a:solidFill>
+                <a:latin typeface="Arial"/>
+              </a:defRPr>
+            </a:pPr>
+            <a:r>
+              <a:t>•  Pinned local gemma4:e4b weights in dedicated 5.1 GB GPU VRAM.</a:t>
+            </a:r>
+          </a:p>
+          <a:p>
+            <a:pPr>
+              <a:spcAft>
+                <a:spcPts val="600"/>
+              </a:spcAft>
+              <a:defRPr sz="1200">
+                <a:solidFill>
+                  <a:srgbClr val="94A3B8"/>
+                </a:solidFill>
+                <a:latin typeface="Arial"/>
+              </a:defRPr>
+            </a:pPr>
+            <a:r>
+              <a:t>•  Configured keep_alive: '-1' to completely eliminate cold-start unloading.</a:t>
+            </a:r>
+          </a:p>
+          <a:p>
+            <a:pPr>
+              <a:spcAft>
+                <a:spcPts val="600"/>
+              </a:spcAft>
+              <a:defRPr sz="1200">
+                <a:solidFill>
+                  <a:srgbClr val="94A3B8"/>
+                </a:solidFill>
+                <a:latin typeface="Arial"/>
+              </a:defRPr>
+            </a:pPr>
+            <a:r>
+              <a:t>•  Instant response velocity: First token streamed in milliseconds.</a:t>
+            </a:r>
+          </a:p>
+          <a:p>
+            <a:pPr>
+              <a:spcAft>
+                <a:spcPts val="600"/>
+              </a:spcAft>
+              <a:defRPr sz="1200">
+                <a:solidFill>
+                  <a:srgbClr val="94A3B8"/>
+                </a:solidFill>
+                <a:latin typeface="Arial"/>
+              </a:defRPr>
+            </a:pPr>
+            <a:r>
+              <a:t>•  Optimized for smooth pair programming and multi-turn conversational agents.</a:t>
+            </a:r>
+          </a:p>
+        </p:txBody>
+      </p:sp>
+      <p:sp>
+        <p:nvSpPr>
+          <p:cNvPr id="8" name="Rounded Rectangle 7"/>
+          <p:cNvSpPr/>
+          <p:nvPr/>
+        </p:nvSpPr>
+        <p:spPr>
+          <a:xfrm>
+            <a:off x="8046720" y="1645920"/>
             <a:ext cx="3383280" cy="4572000"/>
           </a:xfrm>
           <a:prstGeom prst="roundRect">
@@ -8441,7 +9845,7 @@
               </a:defRPr>
             </a:pPr>
             <a:r>
-              <a:t>SOVEREIGNTY</a:t>
+              <a:t>RESILIENCE</a:t>
             </a:r>
           </a:p>
           <a:p>
@@ -8457,7 +9861,7 @@
               </a:defRPr>
             </a:pPr>
             <a:r>
-              <a:t>100% Data Sovereignty</a:t>
+              <a:t>Self-Healing Docker Stack</a:t>
             </a:r>
           </a:p>
           <a:p>
@@ -8473,7 +9877,7 @@
               </a:defRPr>
             </a:pPr>
             <a:r>
-              <a:t>•  Zero cloud leakage: Classified ministerial files remain within the state firewall.</a:t>
+              <a:t>•  11 isolated Docker services: Agent, Platform, ONLYOFFICE, SurrealDB, Postgres, Redis, Kokoro.</a:t>
             </a:r>
           </a:p>
           <a:p>
@@ -8489,7 +9893,7 @@
               </a:defRPr>
             </a:pPr>
             <a:r>
-              <a:t>•  Full compliance with national cybersecurity and data protection frameworks.</a:t>
+              <a:t>•  Built-in runtime self-patching in startServer.js guarantees TRPC stability on container boot.</a:t>
             </a:r>
           </a:p>
           <a:p>
@@ -8505,7 +9909,7 @@
               </a:defRPr>
             </a:pPr>
             <a:r>
-              <a:t>•  Immune to foreign sanctions, cloud pricing hikes, or global connection blackouts.</a:t>
+              <a:t>•  Turnkey 1-click bootstrap scripts (.ps1 and .sh) launch the full ecosystem in under 15 seconds.</a:t>
             </a:r>
           </a:p>
           <a:p>
@@ -8521,283 +9925,7 @@
               </a:defRPr>
             </a:pPr>
             <a:r>
-              <a:t>•  Total ownership of code, weights, data, and fine-tuned domain models.</a:t>
-            </a:r>
-          </a:p>
-        </p:txBody>
-      </p:sp>
-      <p:sp>
-        <p:nvSpPr>
-          <p:cNvPr id="7" name="Rounded Rectangle 6"/>
-          <p:cNvSpPr/>
-          <p:nvPr/>
-        </p:nvSpPr>
-        <p:spPr>
-          <a:xfrm>
-            <a:off x="4389120" y="1645920"/>
-            <a:ext cx="3383280" cy="4572000"/>
-          </a:xfrm>
-          <a:prstGeom prst="roundRect">
-            <a:avLst/>
-          </a:prstGeom>
-          <a:solidFill>
-            <a:srgbClr val="111827"/>
-          </a:solidFill>
-          <a:ln w="15240">
-            <a:solidFill>
-              <a:srgbClr val="D4AF37"/>
-            </a:solidFill>
-          </a:ln>
-        </p:spPr>
-        <p:style>
-          <a:lnRef idx="1">
-            <a:schemeClr val="accent1"/>
-          </a:lnRef>
-          <a:fillRef idx="3">
-            <a:schemeClr val="accent1"/>
-          </a:fillRef>
-          <a:effectRef idx="2">
-            <a:schemeClr val="accent1"/>
-          </a:effectRef>
-          <a:fontRef idx="minor">
-            <a:schemeClr val="lt1"/>
-          </a:fontRef>
-        </p:style>
-        <p:txBody>
-          <a:bodyPr rtlCol="0" anchor="ctr" wrap="square" lIns="228600" rIns="228600" tIns="228600" bIns="182880"/>
-          <a:lstStyle/>
-          <a:p>
-            <a:pPr algn="ctr">
-              <a:spcAft>
-                <a:spcPts val="400"/>
-              </a:spcAft>
-              <a:defRPr sz="1000" b="1">
-                <a:solidFill>
-                  <a:srgbClr val="D4AF37"/>
-                </a:solidFill>
-                <a:latin typeface="Arial"/>
-              </a:defRPr>
-            </a:pPr>
-            <a:r>
-              <a:t>PRODUCTIVITY</a:t>
-            </a:r>
-          </a:p>
-          <a:p>
-            <a:pPr>
-              <a:spcAft>
-                <a:spcPts val="1000"/>
-              </a:spcAft>
-              <a:defRPr sz="1600" b="1">
-                <a:solidFill>
-                  <a:srgbClr val="F8FAFC"/>
-                </a:solidFill>
-                <a:latin typeface="Arial"/>
-              </a:defRPr>
-            </a:pPr>
-            <a:r>
-              <a:t>10x Operational Speed</a:t>
-            </a:r>
-          </a:p>
-          <a:p>
-            <a:pPr>
-              <a:spcAft>
-                <a:spcPts val="600"/>
-              </a:spcAft>
-              <a:defRPr sz="1200">
-                <a:solidFill>
-                  <a:srgbClr val="94A3B8"/>
-                </a:solidFill>
-                <a:latin typeface="Arial"/>
-              </a:defRPr>
-            </a:pPr>
-            <a:r>
-              <a:t>•  Reduces 4-hour document reading to a 30-second verified executive summary.</a:t>
-            </a:r>
-          </a:p>
-          <a:p>
-            <a:pPr>
-              <a:spcAft>
-                <a:spcPts val="600"/>
-              </a:spcAft>
-              <a:defRPr sz="1200">
-                <a:solidFill>
-                  <a:srgbClr val="94A3B8"/>
-                </a:solidFill>
-                <a:latin typeface="Arial"/>
-              </a:defRPr>
-            </a:pPr>
-            <a:r>
-              <a:t>•  Eliminates external design delays: Generates ready-to-present PowerPoint decks on demand.</a:t>
-            </a:r>
-          </a:p>
-          <a:p>
-            <a:pPr>
-              <a:spcAft>
-                <a:spcPts val="600"/>
-              </a:spcAft>
-              <a:defRPr sz="1200">
-                <a:solidFill>
-                  <a:srgbClr val="94A3B8"/>
-                </a:solidFill>
-                <a:latin typeface="Arial"/>
-              </a:defRPr>
-            </a:pPr>
-            <a:r>
-              <a:t>•  Instant ONLYOFFICE co-editing: Staff collaborate inside the platform without license costs.</a:t>
-            </a:r>
-          </a:p>
-          <a:p>
-            <a:pPr>
-              <a:spcAft>
-                <a:spcPts val="600"/>
-              </a:spcAft>
-              <a:defRPr sz="1200">
-                <a:solidFill>
-                  <a:srgbClr val="94A3B8"/>
-                </a:solidFill>
-                <a:latin typeface="Arial"/>
-              </a:defRPr>
-            </a:pPr>
-            <a:r>
-              <a:t>•  Empowers leadership with real-time strategic briefs during meetings.</a:t>
-            </a:r>
-          </a:p>
-        </p:txBody>
-      </p:sp>
-      <p:sp>
-        <p:nvSpPr>
-          <p:cNvPr id="8" name="Rounded Rectangle 7"/>
-          <p:cNvSpPr/>
-          <p:nvPr/>
-        </p:nvSpPr>
-        <p:spPr>
-          <a:xfrm>
-            <a:off x="8046720" y="1645920"/>
-            <a:ext cx="3383280" cy="4572000"/>
-          </a:xfrm>
-          <a:prstGeom prst="roundRect">
-            <a:avLst/>
-          </a:prstGeom>
-          <a:solidFill>
-            <a:srgbClr val="111827"/>
-          </a:solidFill>
-          <a:ln w="15240">
-            <a:solidFill>
-              <a:srgbClr val="38BDF8"/>
-            </a:solidFill>
-          </a:ln>
-        </p:spPr>
-        <p:style>
-          <a:lnRef idx="1">
-            <a:schemeClr val="accent1"/>
-          </a:lnRef>
-          <a:fillRef idx="3">
-            <a:schemeClr val="accent1"/>
-          </a:fillRef>
-          <a:effectRef idx="2">
-            <a:schemeClr val="accent1"/>
-          </a:effectRef>
-          <a:fontRef idx="minor">
-            <a:schemeClr val="lt1"/>
-          </a:fontRef>
-        </p:style>
-        <p:txBody>
-          <a:bodyPr rtlCol="0" anchor="ctr" wrap="square" lIns="228600" rIns="228600" tIns="228600" bIns="182880"/>
-          <a:lstStyle/>
-          <a:p>
-            <a:pPr algn="ctr">
-              <a:spcAft>
-                <a:spcPts val="400"/>
-              </a:spcAft>
-              <a:defRPr sz="1000" b="1">
-                <a:solidFill>
-                  <a:srgbClr val="38BDF8"/>
-                </a:solidFill>
-                <a:latin typeface="Arial"/>
-              </a:defRPr>
-            </a:pPr>
-            <a:r>
-              <a:t>COST EFFICIENCY</a:t>
-            </a:r>
-          </a:p>
-          <a:p>
-            <a:pPr>
-              <a:spcAft>
-                <a:spcPts val="1000"/>
-              </a:spcAft>
-              <a:defRPr sz="1600" b="1">
-                <a:solidFill>
-                  <a:srgbClr val="F8FAFC"/>
-                </a:solidFill>
-                <a:latin typeface="Arial"/>
-              </a:defRPr>
-            </a:pPr>
-            <a:r>
-              <a:t>Zero Recurring SaaS Costs</a:t>
-            </a:r>
-          </a:p>
-          <a:p>
-            <a:pPr>
-              <a:spcAft>
-                <a:spcPts val="600"/>
-              </a:spcAft>
-              <a:defRPr sz="1200">
-                <a:solidFill>
-                  <a:srgbClr val="94A3B8"/>
-                </a:solidFill>
-                <a:latin typeface="Arial"/>
-              </a:defRPr>
-            </a:pPr>
-            <a:r>
-              <a:t>•  No per-seat licensing fees (saving thousands of dollars annually on Copilot / ChatGPT Plus).</a:t>
-            </a:r>
-          </a:p>
-          <a:p>
-            <a:pPr>
-              <a:spcAft>
-                <a:spcPts val="600"/>
-              </a:spcAft>
-              <a:defRPr sz="1200">
-                <a:solidFill>
-                  <a:srgbClr val="94A3B8"/>
-                </a:solidFill>
-                <a:latin typeface="Arial"/>
-              </a:defRPr>
-            </a:pPr>
-            <a:r>
-              <a:t>•  Runs on existing departmental GPUs and workstations without expensive cloud clusters.</a:t>
-            </a:r>
-          </a:p>
-          <a:p>
-            <a:pPr>
-              <a:spcAft>
-                <a:spcPts val="600"/>
-              </a:spcAft>
-              <a:defRPr sz="1200">
-                <a:solidFill>
-                  <a:srgbClr val="94A3B8"/>
-                </a:solidFill>
-                <a:latin typeface="Arial"/>
-              </a:defRPr>
-            </a:pPr>
-            <a:r>
-              <a:t>•  Built on robust open-source foundations (SurrealDB, ParadeDB, Next.js, Fastify).</a:t>
-            </a:r>
-          </a:p>
-          <a:p>
-            <a:pPr>
-              <a:spcAft>
-                <a:spcPts val="600"/>
-              </a:spcAft>
-              <a:defRPr sz="1200">
-                <a:solidFill>
-                  <a:srgbClr val="94A3B8"/>
-                </a:solidFill>
-                <a:latin typeface="Arial"/>
-              </a:defRPr>
-            </a:pPr>
-            <a:r>
-              <a:t>•  Future-proof modularity: swap underlying open models seamlessly.</a:t>
+              <a:t>•  All source code versioned on GitHub: AhmdArFa/TuT-AI.</a:t>
             </a:r>
           </a:p>
         </p:txBody>

</xml_diff>